<commit_message>
Consolidate SSOT·RTL Generator deck into a single English one-pager
- One slide (dark/formal) with four bands: Pipeline (INPUT→SSOT-AGENT→
  OUTPUT→RTL-AGENT→OUTPUT + per-stage components), Agent Loops (orchestrator
  coordination + worker ReAct), TODO Workflow (pending→in_progress→completed→
  approved lifecycle + todo_events), Expected Impact
- English throughout; grounded in workflow scripts + orchestrator/worker tools

Co-Authored-By: Claude Opus 4.7 (1M context) <noreply@anthropic.com>
</commit_message>
<xml_diff>
--- a/common_ai_agent/doc/agent_pipeline_dark.pptx
+++ b/common_ai_agent/doc/agent_pipeline_dark.pptx
@@ -3140,8 +3140,8 @@
         </p:nvSpPr>
         <p:spPr>
           <a:xfrm>
-            <a:off x="502920" y="457200"/>
-            <a:ext cx="64008" cy="960120"/>
+            <a:off x="502920" y="292608"/>
+            <a:ext cx="64008" cy="777240"/>
           </a:xfrm>
           <a:prstGeom prst="rect">
             <a:avLst/>
@@ -3184,8 +3184,8 @@
         </p:nvSpPr>
         <p:spPr>
           <a:xfrm>
-            <a:off x="731520" y="384048"/>
-            <a:ext cx="10972800" cy="310896"/>
+            <a:off x="731520" y="237744"/>
+            <a:ext cx="10972800" cy="274320"/>
           </a:xfrm>
           <a:prstGeom prst="rect">
             <a:avLst/>
@@ -3200,11 +3200,11 @@
           <a:p>
             <a:pPr algn="l">
               <a:spcAft>
-                <a:spcPts val="200"/>
+                <a:spcPts val="100"/>
               </a:spcAft>
             </a:pPr>
             <a:r>
-              <a:rPr sz="1100" b="1">
+              <a:rPr sz="1050" b="1">
                 <a:solidFill>
                   <a:srgbClr val="6B7995"/>
                 </a:solidFill>
@@ -3223,8 +3223,8 @@
         </p:nvSpPr>
         <p:spPr>
           <a:xfrm>
-            <a:off x="713232" y="621792"/>
-            <a:ext cx="10972800" cy="548640"/>
+            <a:off x="713232" y="448056"/>
+            <a:ext cx="10972800" cy="457200"/>
           </a:xfrm>
           <a:prstGeom prst="rect">
             <a:avLst/>
@@ -3239,11 +3239,11 @@
           <a:p>
             <a:pPr algn="l">
               <a:spcAft>
-                <a:spcPts val="200"/>
+                <a:spcPts val="100"/>
               </a:spcAft>
             </a:pPr>
             <a:r>
-              <a:rPr sz="2600" b="1">
+              <a:rPr sz="2300" b="1">
                 <a:solidFill>
                   <a:srgbClr val="FFFFFF"/>
                 </a:solidFill>
@@ -3262,8 +3262,8 @@
         </p:nvSpPr>
         <p:spPr>
           <a:xfrm>
-            <a:off x="731520" y="1133856"/>
-            <a:ext cx="11247120" cy="457200"/>
+            <a:off x="731520" y="886968"/>
+            <a:ext cx="11338560" cy="274320"/>
           </a:xfrm>
           <a:prstGeom prst="rect">
             <a:avLst/>
@@ -3278,17 +3278,17 @@
           <a:p>
             <a:pPr algn="l">
               <a:spcAft>
-                <a:spcPts val="200"/>
+                <a:spcPts val="100"/>
               </a:spcAft>
             </a:pPr>
             <a:r>
-              <a:rPr sz="1200" b="0">
+              <a:rPr sz="1050" b="0">
                 <a:solidFill>
                   <a:srgbClr val="9AAAC6"/>
                 </a:solidFill>
                 <a:latin typeface="Calibri"/>
               </a:rPr>
-              <a:t>An AI agent that turns existing DB knowledge and Q&amp;A into a standardized spec (SSOT),</a:t>
+              <a:t>An AI agent that turns existing DB knowledge and Q&amp;A into a standardized spec (SSOT), then generates synthesizable RTL.</a:t>
             </a:r>
           </a:p>
         </p:txBody>
@@ -3301,8 +3301,8 @@
         </p:nvSpPr>
         <p:spPr>
           <a:xfrm>
-            <a:off x="731520" y="1371600"/>
-            <a:ext cx="11247120" cy="292608"/>
+            <a:off x="713232" y="1280160"/>
+            <a:ext cx="10972800" cy="237744"/>
           </a:xfrm>
           <a:prstGeom prst="rect">
             <a:avLst/>
@@ -3317,17 +3317,17 @@
           <a:p>
             <a:pPr algn="l">
               <a:spcAft>
-                <a:spcPts val="200"/>
+                <a:spcPts val="100"/>
               </a:spcAft>
             </a:pPr>
             <a:r>
-              <a:rPr sz="1200" b="0">
-                <a:solidFill>
-                  <a:srgbClr val="9AAAC6"/>
+              <a:rPr sz="1100" b="1">
+                <a:solidFill>
+                  <a:srgbClr val="35C4AE"/>
                 </a:solidFill>
                 <a:latin typeface="Calibri"/>
               </a:rPr>
-              <a:t>then automatically generates synthesizable RTL from it.</a:t>
+              <a:t>PIPELINE</a:t>
             </a:r>
           </a:p>
         </p:txBody>
@@ -3340,91 +3340,8 @@
         </p:nvSpPr>
         <p:spPr>
           <a:xfrm>
-            <a:off x="0" y="1810512"/>
-            <a:ext cx="12191695" cy="10972"/>
-          </a:xfrm>
-          <a:prstGeom prst="rect">
-            <a:avLst/>
-          </a:prstGeom>
-          <a:solidFill>
-            <a:srgbClr val="2B3852"/>
-          </a:solidFill>
-          <a:ln>
-            <a:noFill/>
-          </a:ln>
-          <a:effectLst/>
-        </p:spPr>
-        <p:style>
-          <a:lnRef idx="1">
-            <a:schemeClr val="accent1"/>
-          </a:lnRef>
-          <a:fillRef idx="3">
-            <a:schemeClr val="accent1"/>
-          </a:fillRef>
-          <a:effectRef idx="2">
-            <a:schemeClr val="accent1"/>
-          </a:effectRef>
-          <a:fontRef idx="minor">
-            <a:schemeClr val="lt1"/>
-          </a:fontRef>
-        </p:style>
-        <p:txBody>
-          <a:bodyPr rtlCol="0" anchor="ctr"/>
-          <a:lstStyle/>
-          <a:p>
-            <a:pPr algn="ctr"/>
-          </a:p>
-        </p:txBody>
-      </p:sp>
-      <p:sp>
-        <p:nvSpPr>
-          <p:cNvPr id="9" name="TextBox 8"/>
-          <p:cNvSpPr txBox="1"/>
-          <p:nvPr/>
-        </p:nvSpPr>
-        <p:spPr>
-          <a:xfrm>
-            <a:off x="731520" y="1865376"/>
-            <a:ext cx="10972800" cy="256032"/>
-          </a:xfrm>
-          <a:prstGeom prst="rect">
-            <a:avLst/>
-          </a:prstGeom>
-          <a:noFill/>
-        </p:spPr>
-        <p:txBody>
-          <a:bodyPr wrap="square" anchor="t">
-            <a:spAutoFit/>
-          </a:bodyPr>
-          <a:lstStyle/>
-          <a:p>
-            <a:pPr algn="r">
-              <a:spcAft>
-                <a:spcPts val="200"/>
-              </a:spcAft>
-            </a:pPr>
-            <a:r>
-              <a:rPr sz="950" b="1">
-                <a:solidFill>
-                  <a:srgbClr val="6B7995"/>
-                </a:solidFill>
-                <a:latin typeface="Calibri"/>
-              </a:rPr>
-              <a:t>■ AGENT  AI-executed      ▢ OUTPUT  artifact      ▸ key components</a:t>
-            </a:r>
-          </a:p>
-        </p:txBody>
-      </p:sp>
-      <p:sp>
-        <p:nvSpPr>
-          <p:cNvPr id="10" name="Rectangle 9"/>
-          <p:cNvSpPr/>
-          <p:nvPr/>
-        </p:nvSpPr>
-        <p:spPr>
-          <a:xfrm>
-            <a:off x="161391" y="2240280"/>
-            <a:ext cx="2395728" cy="2331720"/>
+            <a:off x="243687" y="1554480"/>
+            <a:ext cx="2377440" cy="1280160"/>
           </a:xfrm>
           <a:prstGeom prst="rect">
             <a:avLst/>
@@ -3463,14 +3380,14 @@
       </p:sp>
       <p:sp>
         <p:nvSpPr>
-          <p:cNvPr id="11" name="Rectangle 10"/>
+          <p:cNvPr id="9" name="Rectangle 8"/>
           <p:cNvSpPr/>
           <p:nvPr/>
         </p:nvSpPr>
         <p:spPr>
           <a:xfrm>
-            <a:off x="161391" y="2240280"/>
-            <a:ext cx="2395728" cy="73152"/>
+            <a:off x="243687" y="1554480"/>
+            <a:ext cx="2377440" cy="64008"/>
           </a:xfrm>
           <a:prstGeom prst="rect">
             <a:avLst/>
@@ -3507,14 +3424,14 @@
       </p:sp>
       <p:sp>
         <p:nvSpPr>
-          <p:cNvPr id="12" name="TextBox 11"/>
+          <p:cNvPr id="10" name="TextBox 9"/>
           <p:cNvSpPr txBox="1"/>
           <p:nvPr/>
         </p:nvSpPr>
         <p:spPr>
           <a:xfrm>
-            <a:off x="161391" y="2423160"/>
-            <a:ext cx="2395728" cy="274320"/>
+            <a:off x="243687" y="1664207"/>
+            <a:ext cx="2377440" cy="502920"/>
           </a:xfrm>
           <a:prstGeom prst="rect">
             <a:avLst/>
@@ -3529,11 +3446,11 @@
           <a:p>
             <a:pPr algn="ctr">
               <a:spcAft>
-                <a:spcPts val="200"/>
+                <a:spcPts val="100"/>
               </a:spcAft>
             </a:pPr>
             <a:r>
-              <a:rPr sz="950" b="1">
+              <a:rPr sz="850" b="1">
                 <a:solidFill>
                   <a:srgbClr val="9B8CF0"/>
                 </a:solidFill>
@@ -3542,18 +3459,177 @@
               <a:t>INPUT</a:t>
             </a:r>
           </a:p>
-        </p:txBody>
-      </p:sp>
-      <p:sp>
-        <p:nvSpPr>
-          <p:cNvPr id="13" name="TextBox 12"/>
+          <a:p>
+            <a:pPr algn="ctr">
+              <a:spcAft>
+                <a:spcPts val="100"/>
+              </a:spcAft>
+            </a:pPr>
+            <a:r>
+              <a:rPr sz="1350" b="1">
+                <a:solidFill>
+                  <a:srgbClr val="FFFFFF"/>
+                </a:solidFill>
+                <a:latin typeface="Calibri"/>
+              </a:rPr>
+              <a:t>Requirements</a:t>
+            </a:r>
+          </a:p>
+        </p:txBody>
+      </p:sp>
+      <p:sp>
+        <p:nvSpPr>
+          <p:cNvPr id="11" name="TextBox 10"/>
           <p:cNvSpPr txBox="1"/>
           <p:nvPr/>
         </p:nvSpPr>
         <p:spPr>
           <a:xfrm>
-            <a:off x="161391" y="2715768"/>
-            <a:ext cx="2395728" cy="457200"/>
+            <a:off x="426567" y="2331720"/>
+            <a:ext cx="2048256" cy="457200"/>
+          </a:xfrm>
+          <a:prstGeom prst="rect">
+            <a:avLst/>
+          </a:prstGeom>
+          <a:noFill/>
+        </p:spPr>
+        <p:txBody>
+          <a:bodyPr wrap="square" anchor="t">
+            <a:spAutoFit/>
+          </a:bodyPr>
+          <a:lstStyle/>
+          <a:p>
+            <a:pPr algn="l">
+              <a:spcAft>
+                <a:spcPts val="100"/>
+              </a:spcAft>
+            </a:pPr>
+            <a:r>
+              <a:rPr sz="850" b="0">
+                <a:solidFill>
+                  <a:srgbClr val="9AAAC6"/>
+                </a:solidFill>
+                <a:latin typeface="Calibri"/>
+              </a:rPr>
+              <a:t>▸ AtlasDB (existing DB)</a:t>
+            </a:r>
+          </a:p>
+          <a:p>
+            <a:pPr algn="l">
+              <a:spcAft>
+                <a:spcPts val="100"/>
+              </a:spcAft>
+            </a:pPr>
+            <a:r>
+              <a:rPr sz="850" b="0">
+                <a:solidFill>
+                  <a:srgbClr val="9AAAC6"/>
+                </a:solidFill>
+                <a:latin typeface="Calibri"/>
+              </a:rPr>
+              <a:t>▸ Deep Interview (Q&amp;A)</a:t>
+            </a:r>
+          </a:p>
+        </p:txBody>
+      </p:sp>
+      <p:sp>
+        <p:nvSpPr>
+          <p:cNvPr id="12" name="Right Arrow 11"/>
+          <p:cNvSpPr/>
+          <p:nvPr/>
+        </p:nvSpPr>
+        <p:spPr>
+          <a:xfrm>
+            <a:off x="2611983" y="2112264"/>
+            <a:ext cx="237744" cy="164592"/>
+          </a:xfrm>
+          <a:prstGeom prst="rightArrow">
+            <a:avLst/>
+          </a:prstGeom>
+          <a:solidFill>
+            <a:srgbClr val="6B7995"/>
+          </a:solidFill>
+          <a:ln>
+            <a:noFill/>
+          </a:ln>
+          <a:effectLst/>
+        </p:spPr>
+        <p:style>
+          <a:lnRef idx="1">
+            <a:schemeClr val="accent1"/>
+          </a:lnRef>
+          <a:fillRef idx="3">
+            <a:schemeClr val="accent1"/>
+          </a:fillRef>
+          <a:effectRef idx="2">
+            <a:schemeClr val="accent1"/>
+          </a:effectRef>
+          <a:fontRef idx="minor">
+            <a:schemeClr val="lt1"/>
+          </a:fontRef>
+        </p:style>
+        <p:txBody>
+          <a:bodyPr rtlCol="0" anchor="ctr"/>
+          <a:lstStyle/>
+          <a:p>
+            <a:pPr algn="ctr"/>
+          </a:p>
+        </p:txBody>
+      </p:sp>
+      <p:sp>
+        <p:nvSpPr>
+          <p:cNvPr id="13" name="Rounded Rectangle 12"/>
+          <p:cNvSpPr/>
+          <p:nvPr/>
+        </p:nvSpPr>
+        <p:spPr>
+          <a:xfrm>
+            <a:off x="2804007" y="1554480"/>
+            <a:ext cx="2103120" cy="1280160"/>
+          </a:xfrm>
+          <a:prstGeom prst="roundRect">
+            <a:avLst/>
+          </a:prstGeom>
+          <a:solidFill>
+            <a:srgbClr val="35C4AE"/>
+          </a:solidFill>
+          <a:ln>
+            <a:noFill/>
+          </a:ln>
+          <a:effectLst/>
+        </p:spPr>
+        <p:style>
+          <a:lnRef idx="1">
+            <a:schemeClr val="accent1"/>
+          </a:lnRef>
+          <a:fillRef idx="3">
+            <a:schemeClr val="accent1"/>
+          </a:fillRef>
+          <a:effectRef idx="2">
+            <a:schemeClr val="accent1"/>
+          </a:effectRef>
+          <a:fontRef idx="minor">
+            <a:schemeClr val="lt1"/>
+          </a:fontRef>
+        </p:style>
+        <p:txBody>
+          <a:bodyPr rtlCol="0" anchor="ctr"/>
+          <a:lstStyle/>
+          <a:p>
+            <a:pPr algn="ctr"/>
+          </a:p>
+        </p:txBody>
+      </p:sp>
+      <p:sp>
+        <p:nvSpPr>
+          <p:cNvPr id="14" name="TextBox 13"/>
+          <p:cNvSpPr txBox="1"/>
+          <p:nvPr/>
+        </p:nvSpPr>
+        <p:spPr>
+          <a:xfrm>
+            <a:off x="2804007" y="1645920"/>
+            <a:ext cx="2103120" cy="548640"/>
           </a:xfrm>
           <a:prstGeom prst="rect">
             <a:avLst/>
@@ -3568,31 +3644,732 @@
           <a:p>
             <a:pPr algn="ctr">
               <a:spcAft>
-                <a:spcPts val="200"/>
+                <a:spcPts val="100"/>
               </a:spcAft>
             </a:pPr>
             <a:r>
-              <a:rPr sz="1500" b="1">
-                <a:solidFill>
-                  <a:srgbClr val="FFFFFF"/>
+              <a:rPr sz="800" b="1">
+                <a:solidFill>
+                  <a:srgbClr val="0D1422"/>
                 </a:solidFill>
                 <a:latin typeface="Calibri"/>
               </a:rPr>
-              <a:t>Requirements</a:t>
-            </a:r>
-          </a:p>
-        </p:txBody>
-      </p:sp>
-      <p:sp>
-        <p:nvSpPr>
-          <p:cNvPr id="14" name="Rectangle 13"/>
+              <a:t>◇ AI AGENT</a:t>
+            </a:r>
+          </a:p>
+          <a:p>
+            <a:pPr algn="ctr">
+              <a:spcAft>
+                <a:spcPts val="100"/>
+              </a:spcAft>
+            </a:pPr>
+            <a:r>
+              <a:rPr sz="1300" b="1">
+                <a:solidFill>
+                  <a:srgbClr val="0D1422"/>
+                </a:solidFill>
+                <a:latin typeface="Calibri"/>
+              </a:rPr>
+              <a:t>SSOT-AGENT</a:t>
+            </a:r>
+          </a:p>
+          <a:p>
+            <a:pPr algn="ctr">
+              <a:spcAft>
+                <a:spcPts val="100"/>
+              </a:spcAft>
+            </a:pPr>
+            <a:r>
+              <a:rPr sz="1000" b="0">
+                <a:solidFill>
+                  <a:srgbClr val="0D1422"/>
+                </a:solidFill>
+                <a:latin typeface="Calibri"/>
+              </a:rPr>
+              <a:t>spec gen</a:t>
+            </a:r>
+          </a:p>
+        </p:txBody>
+      </p:sp>
+      <p:sp>
+        <p:nvSpPr>
+          <p:cNvPr id="15" name="TextBox 14"/>
+          <p:cNvSpPr txBox="1"/>
+          <p:nvPr/>
+        </p:nvSpPr>
+        <p:spPr>
+          <a:xfrm>
+            <a:off x="2986887" y="2340864"/>
+            <a:ext cx="1773936" cy="457200"/>
+          </a:xfrm>
+          <a:prstGeom prst="rect">
+            <a:avLst/>
+          </a:prstGeom>
+          <a:noFill/>
+        </p:spPr>
+        <p:txBody>
+          <a:bodyPr wrap="square" anchor="t">
+            <a:spAutoFit/>
+          </a:bodyPr>
+          <a:lstStyle/>
+          <a:p>
+            <a:pPr algn="l">
+              <a:spcAft>
+                <a:spcPts val="100"/>
+              </a:spcAft>
+            </a:pPr>
+            <a:r>
+              <a:rPr sz="850" b="0">
+                <a:solidFill>
+                  <a:srgbClr val="0D1422"/>
+                </a:solidFill>
+                <a:latin typeface="Calibri"/>
+              </a:rPr>
+              <a:t>▸ ssot-gen (LLM)</a:t>
+            </a:r>
+          </a:p>
+          <a:p>
+            <a:pPr algn="l">
+              <a:spcAft>
+                <a:spcPts val="100"/>
+              </a:spcAft>
+            </a:pPr>
+            <a:r>
+              <a:rPr sz="850" b="0">
+                <a:solidFill>
+                  <a:srgbClr val="0D1422"/>
+                </a:solidFill>
+                <a:latin typeface="Calibri"/>
+              </a:rPr>
+              <a:t>▸ verify_ssot.py</a:t>
+            </a:r>
+          </a:p>
+        </p:txBody>
+      </p:sp>
+      <p:sp>
+        <p:nvSpPr>
+          <p:cNvPr id="16" name="Right Arrow 15"/>
           <p:cNvSpPr/>
           <p:nvPr/>
         </p:nvSpPr>
         <p:spPr>
           <a:xfrm>
-            <a:off x="417423" y="3429000"/>
-            <a:ext cx="1883664" cy="10972"/>
+            <a:off x="4897983" y="2112264"/>
+            <a:ext cx="237744" cy="164592"/>
+          </a:xfrm>
+          <a:prstGeom prst="rightArrow">
+            <a:avLst/>
+          </a:prstGeom>
+          <a:solidFill>
+            <a:srgbClr val="35C4AE"/>
+          </a:solidFill>
+          <a:ln>
+            <a:noFill/>
+          </a:ln>
+          <a:effectLst/>
+        </p:spPr>
+        <p:style>
+          <a:lnRef idx="1">
+            <a:schemeClr val="accent1"/>
+          </a:lnRef>
+          <a:fillRef idx="3">
+            <a:schemeClr val="accent1"/>
+          </a:fillRef>
+          <a:effectRef idx="2">
+            <a:schemeClr val="accent1"/>
+          </a:effectRef>
+          <a:fontRef idx="minor">
+            <a:schemeClr val="lt1"/>
+          </a:fontRef>
+        </p:style>
+        <p:txBody>
+          <a:bodyPr rtlCol="0" anchor="ctr"/>
+          <a:lstStyle/>
+          <a:p>
+            <a:pPr algn="ctr"/>
+          </a:p>
+        </p:txBody>
+      </p:sp>
+      <p:sp>
+        <p:nvSpPr>
+          <p:cNvPr id="17" name="Document 16"/>
+          <p:cNvSpPr/>
+          <p:nvPr/>
+        </p:nvSpPr>
+        <p:spPr>
+          <a:xfrm>
+            <a:off x="5090007" y="1554480"/>
+            <a:ext cx="2194560" cy="1353312"/>
+          </a:xfrm>
+          <a:prstGeom prst="flowChartDocument">
+            <a:avLst/>
+          </a:prstGeom>
+          <a:solidFill>
+            <a:srgbClr val="182136"/>
+          </a:solidFill>
+          <a:ln w="25400">
+            <a:solidFill>
+              <a:srgbClr val="35C4AE"/>
+            </a:solidFill>
+          </a:ln>
+          <a:effectLst/>
+        </p:spPr>
+        <p:style>
+          <a:lnRef idx="1">
+            <a:schemeClr val="accent1"/>
+          </a:lnRef>
+          <a:fillRef idx="3">
+            <a:schemeClr val="accent1"/>
+          </a:fillRef>
+          <a:effectRef idx="2">
+            <a:schemeClr val="accent1"/>
+          </a:effectRef>
+          <a:fontRef idx="minor">
+            <a:schemeClr val="lt1"/>
+          </a:fontRef>
+        </p:style>
+        <p:txBody>
+          <a:bodyPr rtlCol="0" anchor="ctr"/>
+          <a:lstStyle/>
+          <a:p>
+            <a:pPr algn="ctr"/>
+          </a:p>
+        </p:txBody>
+      </p:sp>
+      <p:sp>
+        <p:nvSpPr>
+          <p:cNvPr id="18" name="TextBox 17"/>
+          <p:cNvSpPr txBox="1"/>
+          <p:nvPr/>
+        </p:nvSpPr>
+        <p:spPr>
+          <a:xfrm>
+            <a:off x="5090007" y="1664207"/>
+            <a:ext cx="2194560" cy="502920"/>
+          </a:xfrm>
+          <a:prstGeom prst="rect">
+            <a:avLst/>
+          </a:prstGeom>
+          <a:noFill/>
+        </p:spPr>
+        <p:txBody>
+          <a:bodyPr wrap="square" anchor="ctr">
+            <a:spAutoFit/>
+          </a:bodyPr>
+          <a:lstStyle/>
+          <a:p>
+            <a:pPr algn="ctr">
+              <a:spcAft>
+                <a:spcPts val="100"/>
+              </a:spcAft>
+            </a:pPr>
+            <a:r>
+              <a:rPr sz="850" b="1">
+                <a:solidFill>
+                  <a:srgbClr val="35C4AE"/>
+                </a:solidFill>
+                <a:latin typeface="Calibri"/>
+              </a:rPr>
+              <a:t>OUTPUT</a:t>
+            </a:r>
+          </a:p>
+          <a:p>
+            <a:pPr algn="ctr">
+              <a:spcAft>
+                <a:spcPts val="100"/>
+              </a:spcAft>
+            </a:pPr>
+            <a:r>
+              <a:rPr sz="1500" b="1">
+                <a:solidFill>
+                  <a:srgbClr val="35C4AE"/>
+                </a:solidFill>
+                <a:latin typeface="Calibri"/>
+              </a:rPr>
+              <a:t>SSOT</a:t>
+            </a:r>
+          </a:p>
+        </p:txBody>
+      </p:sp>
+      <p:sp>
+        <p:nvSpPr>
+          <p:cNvPr id="19" name="TextBox 18"/>
+          <p:cNvSpPr txBox="1"/>
+          <p:nvPr/>
+        </p:nvSpPr>
+        <p:spPr>
+          <a:xfrm>
+            <a:off x="5272887" y="2331720"/>
+            <a:ext cx="1865376" cy="457200"/>
+          </a:xfrm>
+          <a:prstGeom prst="rect">
+            <a:avLst/>
+          </a:prstGeom>
+          <a:noFill/>
+        </p:spPr>
+        <p:txBody>
+          <a:bodyPr wrap="square" anchor="t">
+            <a:spAutoFit/>
+          </a:bodyPr>
+          <a:lstStyle/>
+          <a:p>
+            <a:pPr algn="l">
+              <a:spcAft>
+                <a:spcPts val="100"/>
+              </a:spcAft>
+            </a:pPr>
+            <a:r>
+              <a:rPr sz="850" b="0">
+                <a:solidFill>
+                  <a:srgbClr val="9AAAC6"/>
+                </a:solidFill>
+                <a:latin typeface="Calibri"/>
+              </a:rPr>
+              <a:t>▸ &lt;ip&gt;.ssot.yaml</a:t>
+            </a:r>
+          </a:p>
+          <a:p>
+            <a:pPr algn="l">
+              <a:spcAft>
+                <a:spcPts val="100"/>
+              </a:spcAft>
+            </a:pPr>
+            <a:r>
+              <a:rPr sz="850" b="0">
+                <a:solidFill>
+                  <a:srgbClr val="9AAAC6"/>
+                </a:solidFill>
+                <a:latin typeface="Calibri"/>
+              </a:rPr>
+              <a:t>▸ 20-section spec</a:t>
+            </a:r>
+          </a:p>
+        </p:txBody>
+      </p:sp>
+      <p:sp>
+        <p:nvSpPr>
+          <p:cNvPr id="20" name="Right Arrow 19"/>
+          <p:cNvSpPr/>
+          <p:nvPr/>
+        </p:nvSpPr>
+        <p:spPr>
+          <a:xfrm>
+            <a:off x="7275423" y="2112264"/>
+            <a:ext cx="237744" cy="164592"/>
+          </a:xfrm>
+          <a:prstGeom prst="rightArrow">
+            <a:avLst/>
+          </a:prstGeom>
+          <a:solidFill>
+            <a:srgbClr val="6B7995"/>
+          </a:solidFill>
+          <a:ln>
+            <a:noFill/>
+          </a:ln>
+          <a:effectLst/>
+        </p:spPr>
+        <p:style>
+          <a:lnRef idx="1">
+            <a:schemeClr val="accent1"/>
+          </a:lnRef>
+          <a:fillRef idx="3">
+            <a:schemeClr val="accent1"/>
+          </a:fillRef>
+          <a:effectRef idx="2">
+            <a:schemeClr val="accent1"/>
+          </a:effectRef>
+          <a:fontRef idx="minor">
+            <a:schemeClr val="lt1"/>
+          </a:fontRef>
+        </p:style>
+        <p:txBody>
+          <a:bodyPr rtlCol="0" anchor="ctr"/>
+          <a:lstStyle/>
+          <a:p>
+            <a:pPr algn="ctr"/>
+          </a:p>
+        </p:txBody>
+      </p:sp>
+      <p:sp>
+        <p:nvSpPr>
+          <p:cNvPr id="21" name="Rounded Rectangle 20"/>
+          <p:cNvSpPr/>
+          <p:nvPr/>
+        </p:nvSpPr>
+        <p:spPr>
+          <a:xfrm>
+            <a:off x="7467447" y="1554480"/>
+            <a:ext cx="2103120" cy="1280160"/>
+          </a:xfrm>
+          <a:prstGeom prst="roundRect">
+            <a:avLst/>
+          </a:prstGeom>
+          <a:solidFill>
+            <a:srgbClr val="EAA83A"/>
+          </a:solidFill>
+          <a:ln>
+            <a:noFill/>
+          </a:ln>
+          <a:effectLst/>
+        </p:spPr>
+        <p:style>
+          <a:lnRef idx="1">
+            <a:schemeClr val="accent1"/>
+          </a:lnRef>
+          <a:fillRef idx="3">
+            <a:schemeClr val="accent1"/>
+          </a:fillRef>
+          <a:effectRef idx="2">
+            <a:schemeClr val="accent1"/>
+          </a:effectRef>
+          <a:fontRef idx="minor">
+            <a:schemeClr val="lt1"/>
+          </a:fontRef>
+        </p:style>
+        <p:txBody>
+          <a:bodyPr rtlCol="0" anchor="ctr"/>
+          <a:lstStyle/>
+          <a:p>
+            <a:pPr algn="ctr"/>
+          </a:p>
+        </p:txBody>
+      </p:sp>
+      <p:sp>
+        <p:nvSpPr>
+          <p:cNvPr id="22" name="TextBox 21"/>
+          <p:cNvSpPr txBox="1"/>
+          <p:nvPr/>
+        </p:nvSpPr>
+        <p:spPr>
+          <a:xfrm>
+            <a:off x="7467447" y="1645920"/>
+            <a:ext cx="2103120" cy="548640"/>
+          </a:xfrm>
+          <a:prstGeom prst="rect">
+            <a:avLst/>
+          </a:prstGeom>
+          <a:noFill/>
+        </p:spPr>
+        <p:txBody>
+          <a:bodyPr wrap="square" anchor="ctr">
+            <a:spAutoFit/>
+          </a:bodyPr>
+          <a:lstStyle/>
+          <a:p>
+            <a:pPr algn="ctr">
+              <a:spcAft>
+                <a:spcPts val="100"/>
+              </a:spcAft>
+            </a:pPr>
+            <a:r>
+              <a:rPr sz="800" b="1">
+                <a:solidFill>
+                  <a:srgbClr val="0D1422"/>
+                </a:solidFill>
+                <a:latin typeface="Calibri"/>
+              </a:rPr>
+              <a:t>◇ AI AGENT</a:t>
+            </a:r>
+          </a:p>
+          <a:p>
+            <a:pPr algn="ctr">
+              <a:spcAft>
+                <a:spcPts val="100"/>
+              </a:spcAft>
+            </a:pPr>
+            <a:r>
+              <a:rPr sz="1300" b="1">
+                <a:solidFill>
+                  <a:srgbClr val="0D1422"/>
+                </a:solidFill>
+                <a:latin typeface="Calibri"/>
+              </a:rPr>
+              <a:t>RTL-AGENT</a:t>
+            </a:r>
+          </a:p>
+          <a:p>
+            <a:pPr algn="ctr">
+              <a:spcAft>
+                <a:spcPts val="100"/>
+              </a:spcAft>
+            </a:pPr>
+            <a:r>
+              <a:rPr sz="1000" b="0">
+                <a:solidFill>
+                  <a:srgbClr val="0D1422"/>
+                </a:solidFill>
+                <a:latin typeface="Calibri"/>
+              </a:rPr>
+              <a:t>RTL gen</a:t>
+            </a:r>
+          </a:p>
+        </p:txBody>
+      </p:sp>
+      <p:sp>
+        <p:nvSpPr>
+          <p:cNvPr id="23" name="TextBox 22"/>
+          <p:cNvSpPr txBox="1"/>
+          <p:nvPr/>
+        </p:nvSpPr>
+        <p:spPr>
+          <a:xfrm>
+            <a:off x="7650327" y="2340864"/>
+            <a:ext cx="1773936" cy="457200"/>
+          </a:xfrm>
+          <a:prstGeom prst="rect">
+            <a:avLst/>
+          </a:prstGeom>
+          <a:noFill/>
+        </p:spPr>
+        <p:txBody>
+          <a:bodyPr wrap="square" anchor="t">
+            <a:spAutoFit/>
+          </a:bodyPr>
+          <a:lstStyle/>
+          <a:p>
+            <a:pPr algn="l">
+              <a:spcAft>
+                <a:spcPts val="100"/>
+              </a:spcAft>
+            </a:pPr>
+            <a:r>
+              <a:rPr sz="850" b="0">
+                <a:solidFill>
+                  <a:srgbClr val="0D1422"/>
+                </a:solidFill>
+                <a:latin typeface="Calibri"/>
+              </a:rPr>
+              <a:t>▸ ssot_to_rtl.py (LLM)</a:t>
+            </a:r>
+          </a:p>
+          <a:p>
+            <a:pPr algn="l">
+              <a:spcAft>
+                <a:spcPts val="100"/>
+              </a:spcAft>
+            </a:pPr>
+            <a:r>
+              <a:rPr sz="850" b="0">
+                <a:solidFill>
+                  <a:srgbClr val="0D1422"/>
+                </a:solidFill>
+                <a:latin typeface="Calibri"/>
+              </a:rPr>
+              <a:t>▸ build_gate.sh</a:t>
+            </a:r>
+          </a:p>
+        </p:txBody>
+      </p:sp>
+      <p:sp>
+        <p:nvSpPr>
+          <p:cNvPr id="24" name="Right Arrow 23"/>
+          <p:cNvSpPr/>
+          <p:nvPr/>
+        </p:nvSpPr>
+        <p:spPr>
+          <a:xfrm>
+            <a:off x="9561423" y="2112264"/>
+            <a:ext cx="237744" cy="164592"/>
+          </a:xfrm>
+          <a:prstGeom prst="rightArrow">
+            <a:avLst/>
+          </a:prstGeom>
+          <a:solidFill>
+            <a:srgbClr val="EAA83A"/>
+          </a:solidFill>
+          <a:ln>
+            <a:noFill/>
+          </a:ln>
+          <a:effectLst/>
+        </p:spPr>
+        <p:style>
+          <a:lnRef idx="1">
+            <a:schemeClr val="accent1"/>
+          </a:lnRef>
+          <a:fillRef idx="3">
+            <a:schemeClr val="accent1"/>
+          </a:fillRef>
+          <a:effectRef idx="2">
+            <a:schemeClr val="accent1"/>
+          </a:effectRef>
+          <a:fontRef idx="minor">
+            <a:schemeClr val="lt1"/>
+          </a:fontRef>
+        </p:style>
+        <p:txBody>
+          <a:bodyPr rtlCol="0" anchor="ctr"/>
+          <a:lstStyle/>
+          <a:p>
+            <a:pPr algn="ctr"/>
+          </a:p>
+        </p:txBody>
+      </p:sp>
+      <p:sp>
+        <p:nvSpPr>
+          <p:cNvPr id="25" name="Document 24"/>
+          <p:cNvSpPr/>
+          <p:nvPr/>
+        </p:nvSpPr>
+        <p:spPr>
+          <a:xfrm>
+            <a:off x="9753447" y="1554480"/>
+            <a:ext cx="2194560" cy="1353312"/>
+          </a:xfrm>
+          <a:prstGeom prst="flowChartDocument">
+            <a:avLst/>
+          </a:prstGeom>
+          <a:solidFill>
+            <a:srgbClr val="182136"/>
+          </a:solidFill>
+          <a:ln w="25400">
+            <a:solidFill>
+              <a:srgbClr val="EAA83A"/>
+            </a:solidFill>
+          </a:ln>
+          <a:effectLst/>
+        </p:spPr>
+        <p:style>
+          <a:lnRef idx="1">
+            <a:schemeClr val="accent1"/>
+          </a:lnRef>
+          <a:fillRef idx="3">
+            <a:schemeClr val="accent1"/>
+          </a:fillRef>
+          <a:effectRef idx="2">
+            <a:schemeClr val="accent1"/>
+          </a:effectRef>
+          <a:fontRef idx="minor">
+            <a:schemeClr val="lt1"/>
+          </a:fontRef>
+        </p:style>
+        <p:txBody>
+          <a:bodyPr rtlCol="0" anchor="ctr"/>
+          <a:lstStyle/>
+          <a:p>
+            <a:pPr algn="ctr"/>
+          </a:p>
+        </p:txBody>
+      </p:sp>
+      <p:sp>
+        <p:nvSpPr>
+          <p:cNvPr id="26" name="TextBox 25"/>
+          <p:cNvSpPr txBox="1"/>
+          <p:nvPr/>
+        </p:nvSpPr>
+        <p:spPr>
+          <a:xfrm>
+            <a:off x="9753447" y="1664207"/>
+            <a:ext cx="2194560" cy="502920"/>
+          </a:xfrm>
+          <a:prstGeom prst="rect">
+            <a:avLst/>
+          </a:prstGeom>
+          <a:noFill/>
+        </p:spPr>
+        <p:txBody>
+          <a:bodyPr wrap="square" anchor="ctr">
+            <a:spAutoFit/>
+          </a:bodyPr>
+          <a:lstStyle/>
+          <a:p>
+            <a:pPr algn="ctr">
+              <a:spcAft>
+                <a:spcPts val="100"/>
+              </a:spcAft>
+            </a:pPr>
+            <a:r>
+              <a:rPr sz="850" b="1">
+                <a:solidFill>
+                  <a:srgbClr val="EAA83A"/>
+                </a:solidFill>
+                <a:latin typeface="Calibri"/>
+              </a:rPr>
+              <a:t>OUTPUT</a:t>
+            </a:r>
+          </a:p>
+          <a:p>
+            <a:pPr algn="ctr">
+              <a:spcAft>
+                <a:spcPts val="100"/>
+              </a:spcAft>
+            </a:pPr>
+            <a:r>
+              <a:rPr sz="1500" b="1">
+                <a:solidFill>
+                  <a:srgbClr val="EAA83A"/>
+                </a:solidFill>
+                <a:latin typeface="Calibri"/>
+              </a:rPr>
+              <a:t>RTL</a:t>
+            </a:r>
+          </a:p>
+        </p:txBody>
+      </p:sp>
+      <p:sp>
+        <p:nvSpPr>
+          <p:cNvPr id="27" name="TextBox 26"/>
+          <p:cNvSpPr txBox="1"/>
+          <p:nvPr/>
+        </p:nvSpPr>
+        <p:spPr>
+          <a:xfrm>
+            <a:off x="9936327" y="2331720"/>
+            <a:ext cx="1865376" cy="457200"/>
+          </a:xfrm>
+          <a:prstGeom prst="rect">
+            <a:avLst/>
+          </a:prstGeom>
+          <a:noFill/>
+        </p:spPr>
+        <p:txBody>
+          <a:bodyPr wrap="square" anchor="t">
+            <a:spAutoFit/>
+          </a:bodyPr>
+          <a:lstStyle/>
+          <a:p>
+            <a:pPr algn="l">
+              <a:spcAft>
+                <a:spcPts val="100"/>
+              </a:spcAft>
+            </a:pPr>
+            <a:r>
+              <a:rPr sz="850" b="0">
+                <a:solidFill>
+                  <a:srgbClr val="9AAAC6"/>
+                </a:solidFill>
+                <a:latin typeface="Calibri"/>
+              </a:rPr>
+              <a:t>▸ &lt;ip&gt;.sv</a:t>
+            </a:r>
+          </a:p>
+          <a:p>
+            <a:pPr algn="l">
+              <a:spcAft>
+                <a:spcPts val="100"/>
+              </a:spcAft>
+            </a:pPr>
+            <a:r>
+              <a:rPr sz="850" b="0">
+                <a:solidFill>
+                  <a:srgbClr val="9AAAC6"/>
+                </a:solidFill>
+                <a:latin typeface="Calibri"/>
+              </a:rPr>
+              <a:t>▸ compile + gate</a:t>
+            </a:r>
+          </a:p>
+        </p:txBody>
+      </p:sp>
+      <p:sp>
+        <p:nvSpPr>
+          <p:cNvPr id="28" name="Rectangle 27"/>
+          <p:cNvSpPr/>
+          <p:nvPr/>
+        </p:nvSpPr>
+        <p:spPr>
+          <a:xfrm>
+            <a:off x="0" y="3035808"/>
+            <a:ext cx="12191695" cy="9144"/>
           </a:xfrm>
           <a:prstGeom prst="rect">
             <a:avLst/>
@@ -3629,14 +4406,14 @@
       </p:sp>
       <p:sp>
         <p:nvSpPr>
-          <p:cNvPr id="15" name="TextBox 14"/>
+          <p:cNvPr id="29" name="TextBox 28"/>
           <p:cNvSpPr txBox="1"/>
           <p:nvPr/>
         </p:nvSpPr>
         <p:spPr>
           <a:xfrm>
-            <a:off x="362559" y="3520440"/>
-            <a:ext cx="2029968" cy="914400"/>
+            <a:off x="713232" y="3108960"/>
+            <a:ext cx="10972800" cy="237744"/>
           </a:xfrm>
           <a:prstGeom prst="rect">
             <a:avLst/>
@@ -3651,63 +4428,316 @@
           <a:p>
             <a:pPr algn="l">
               <a:spcAft>
-                <a:spcPts val="300"/>
+                <a:spcPts val="100"/>
               </a:spcAft>
             </a:pPr>
             <a:r>
-              <a:rPr sz="900" b="0">
-                <a:solidFill>
-                  <a:srgbClr val="9AAAC6"/>
+              <a:rPr sz="1100" b="1">
+                <a:solidFill>
+                  <a:srgbClr val="EAA83A"/>
                 </a:solidFill>
                 <a:latin typeface="Calibri"/>
               </a:rPr>
-              <a:t>▸ AtlasDB (existing DB)</a:t>
-            </a:r>
-          </a:p>
+              <a:t>AGENT LOOPS</a:t>
+            </a:r>
+          </a:p>
+        </p:txBody>
+      </p:sp>
+      <p:sp>
+        <p:nvSpPr>
+          <p:cNvPr id="30" name="TextBox 29"/>
+          <p:cNvSpPr txBox="1"/>
+          <p:nvPr/>
+        </p:nvSpPr>
+        <p:spPr>
+          <a:xfrm>
+            <a:off x="731520" y="3364992"/>
+            <a:ext cx="11430000" cy="274320"/>
+          </a:xfrm>
+          <a:prstGeom prst="rect">
+            <a:avLst/>
+          </a:prstGeom>
+          <a:noFill/>
+        </p:spPr>
+        <p:txBody>
+          <a:bodyPr wrap="square" anchor="t">
+            <a:spAutoFit/>
+          </a:bodyPr>
+          <a:lstStyle/>
           <a:p>
             <a:pPr algn="l">
               <a:spcAft>
-                <a:spcPts val="300"/>
+                <a:spcPts val="100"/>
               </a:spcAft>
             </a:pPr>
             <a:r>
-              <a:rPr sz="900" b="0">
+              <a:rPr sz="1100" b="0">
                 <a:solidFill>
                   <a:srgbClr val="9AAAC6"/>
                 </a:solidFill>
                 <a:latin typeface="Calibri"/>
               </a:rPr>
-              <a:t>▸ import_document (PDF→req)</a:t>
-            </a:r>
-          </a:p>
+              <a:t>Orchestrator:  read_pipeline_state  →  dispatch_workflow  →  yield_run  ↻ wake on job/user</a:t>
+            </a:r>
+          </a:p>
+        </p:txBody>
+      </p:sp>
+      <p:sp>
+        <p:nvSpPr>
+          <p:cNvPr id="31" name="TextBox 30"/>
+          <p:cNvSpPr txBox="1"/>
+          <p:nvPr/>
+        </p:nvSpPr>
+        <p:spPr>
+          <a:xfrm>
+            <a:off x="731520" y="3621024"/>
+            <a:ext cx="11430000" cy="274320"/>
+          </a:xfrm>
+          <a:prstGeom prst="rect">
+            <a:avLst/>
+          </a:prstGeom>
+          <a:noFill/>
+        </p:spPr>
+        <p:txBody>
+          <a:bodyPr wrap="square" anchor="t">
+            <a:spAutoFit/>
+          </a:bodyPr>
+          <a:lstStyle/>
           <a:p>
             <a:pPr algn="l">
               <a:spcAft>
-                <a:spcPts val="300"/>
+                <a:spcPts val="100"/>
               </a:spcAft>
             </a:pPr>
             <a:r>
-              <a:rPr sz="900" b="0">
+              <a:rPr sz="1100" b="0">
                 <a:solidFill>
                   <a:srgbClr val="9AAAC6"/>
                 </a:solidFill>
                 <a:latin typeface="Calibri"/>
               </a:rPr>
-              <a:t>▸ Deep Interview (Q&amp;A)</a:t>
-            </a:r>
-          </a:p>
-        </p:txBody>
-      </p:sp>
-      <p:sp>
-        <p:nvSpPr>
-          <p:cNvPr id="16" name="Right Arrow 15"/>
+              <a:t>Worker (ReAct):  Observe  →  Reason (LLM)  →  Act  ↻ until done  →  emit + gate</a:t>
+            </a:r>
+          </a:p>
+        </p:txBody>
+      </p:sp>
+      <p:sp>
+        <p:nvSpPr>
+          <p:cNvPr id="32" name="TextBox 31"/>
+          <p:cNvSpPr txBox="1"/>
+          <p:nvPr/>
+        </p:nvSpPr>
+        <p:spPr>
+          <a:xfrm>
+            <a:off x="731520" y="3877056"/>
+            <a:ext cx="11430000" cy="256032"/>
+          </a:xfrm>
+          <a:prstGeom prst="rect">
+            <a:avLst/>
+          </a:prstGeom>
+          <a:noFill/>
+        </p:spPr>
+        <p:txBody>
+          <a:bodyPr wrap="square" anchor="t">
+            <a:spAutoFit/>
+          </a:bodyPr>
+          <a:lstStyle/>
+          <a:p>
+            <a:pPr algn="l">
+              <a:spcAft>
+                <a:spcPts val="100"/>
+              </a:spcAft>
+            </a:pPr>
+            <a:r>
+              <a:rPr sz="850" b="0">
+                <a:solidFill>
+                  <a:srgbClr val="6B7995"/>
+                </a:solidFill>
+                <a:latin typeface="Calibri"/>
+              </a:rPr>
+              <a:t>tools — orch: read_pipeline_state · dispatch_workflow · ask_user      worker: read_file · replace_in_file · run_command · todo_write</a:t>
+            </a:r>
+          </a:p>
+        </p:txBody>
+      </p:sp>
+      <p:sp>
+        <p:nvSpPr>
+          <p:cNvPr id="33" name="Rectangle 32"/>
           <p:cNvSpPr/>
           <p:nvPr/>
         </p:nvSpPr>
         <p:spPr>
           <a:xfrm>
-            <a:off x="2547975" y="3314700"/>
-            <a:ext cx="274320" cy="182880"/>
+            <a:off x="0" y="4224528"/>
+            <a:ext cx="12191695" cy="9144"/>
+          </a:xfrm>
+          <a:prstGeom prst="rect">
+            <a:avLst/>
+          </a:prstGeom>
+          <a:solidFill>
+            <a:srgbClr val="2B3852"/>
+          </a:solidFill>
+          <a:ln>
+            <a:noFill/>
+          </a:ln>
+          <a:effectLst/>
+        </p:spPr>
+        <p:style>
+          <a:lnRef idx="1">
+            <a:schemeClr val="accent1"/>
+          </a:lnRef>
+          <a:fillRef idx="3">
+            <a:schemeClr val="accent1"/>
+          </a:fillRef>
+          <a:effectRef idx="2">
+            <a:schemeClr val="accent1"/>
+          </a:effectRef>
+          <a:fontRef idx="minor">
+            <a:schemeClr val="lt1"/>
+          </a:fontRef>
+        </p:style>
+        <p:txBody>
+          <a:bodyPr rtlCol="0" anchor="ctr"/>
+          <a:lstStyle/>
+          <a:p>
+            <a:pPr algn="ctr"/>
+          </a:p>
+        </p:txBody>
+      </p:sp>
+      <p:sp>
+        <p:nvSpPr>
+          <p:cNvPr id="34" name="TextBox 33"/>
+          <p:cNvSpPr txBox="1"/>
+          <p:nvPr/>
+        </p:nvSpPr>
+        <p:spPr>
+          <a:xfrm>
+            <a:off x="713232" y="4297680"/>
+            <a:ext cx="10972800" cy="237744"/>
+          </a:xfrm>
+          <a:prstGeom prst="rect">
+            <a:avLst/>
+          </a:prstGeom>
+          <a:noFill/>
+        </p:spPr>
+        <p:txBody>
+          <a:bodyPr wrap="square" anchor="t">
+            <a:spAutoFit/>
+          </a:bodyPr>
+          <a:lstStyle/>
+          <a:p>
+            <a:pPr algn="l">
+              <a:spcAft>
+                <a:spcPts val="100"/>
+              </a:spcAft>
+            </a:pPr>
+            <a:r>
+              <a:rPr sz="1100" b="1">
+                <a:solidFill>
+                  <a:srgbClr val="5A97F5"/>
+                </a:solidFill>
+                <a:latin typeface="Calibri"/>
+              </a:rPr>
+              <a:t>TODO WORKFLOW</a:t>
+            </a:r>
+          </a:p>
+        </p:txBody>
+      </p:sp>
+      <p:sp>
+        <p:nvSpPr>
+          <p:cNvPr id="35" name="Rounded Rectangle 34"/>
+          <p:cNvSpPr/>
+          <p:nvPr/>
+        </p:nvSpPr>
+        <p:spPr>
+          <a:xfrm>
+            <a:off x="868680" y="4572000"/>
+            <a:ext cx="2057400" cy="502920"/>
+          </a:xfrm>
+          <a:prstGeom prst="roundRect">
+            <a:avLst/>
+          </a:prstGeom>
+          <a:solidFill>
+            <a:srgbClr val="182136"/>
+          </a:solidFill>
+          <a:ln w="22225">
+            <a:solidFill>
+              <a:srgbClr val="6B7995"/>
+            </a:solidFill>
+          </a:ln>
+          <a:effectLst/>
+        </p:spPr>
+        <p:style>
+          <a:lnRef idx="1">
+            <a:schemeClr val="accent1"/>
+          </a:lnRef>
+          <a:fillRef idx="3">
+            <a:schemeClr val="accent1"/>
+          </a:fillRef>
+          <a:effectRef idx="2">
+            <a:schemeClr val="accent1"/>
+          </a:effectRef>
+          <a:fontRef idx="minor">
+            <a:schemeClr val="lt1"/>
+          </a:fontRef>
+        </p:style>
+        <p:txBody>
+          <a:bodyPr rtlCol="0" anchor="ctr"/>
+          <a:lstStyle/>
+          <a:p>
+            <a:pPr algn="ctr"/>
+          </a:p>
+        </p:txBody>
+      </p:sp>
+      <p:sp>
+        <p:nvSpPr>
+          <p:cNvPr id="36" name="TextBox 35"/>
+          <p:cNvSpPr txBox="1"/>
+          <p:nvPr/>
+        </p:nvSpPr>
+        <p:spPr>
+          <a:xfrm>
+            <a:off x="868680" y="4572000"/>
+            <a:ext cx="2057400" cy="502920"/>
+          </a:xfrm>
+          <a:prstGeom prst="rect">
+            <a:avLst/>
+          </a:prstGeom>
+          <a:noFill/>
+        </p:spPr>
+        <p:txBody>
+          <a:bodyPr wrap="square" anchor="ctr">
+            <a:spAutoFit/>
+          </a:bodyPr>
+          <a:lstStyle/>
+          <a:p>
+            <a:pPr algn="ctr">
+              <a:spcAft>
+                <a:spcPts val="100"/>
+              </a:spcAft>
+            </a:pPr>
+            <a:r>
+              <a:rPr sz="1150" b="1">
+                <a:solidFill>
+                  <a:srgbClr val="6B7995"/>
+                </a:solidFill>
+                <a:latin typeface="Calibri"/>
+              </a:rPr>
+              <a:t>PENDING</a:t>
+            </a:r>
+          </a:p>
+        </p:txBody>
+      </p:sp>
+      <p:sp>
+        <p:nvSpPr>
+          <p:cNvPr id="37" name="Right Arrow 36"/>
+          <p:cNvSpPr/>
+          <p:nvPr/>
+        </p:nvSpPr>
+        <p:spPr>
+          <a:xfrm>
+            <a:off x="2971800" y="4750308"/>
+            <a:ext cx="292607" cy="146304"/>
           </a:xfrm>
           <a:prstGeom prst="rightArrow">
             <a:avLst/>
@@ -3744,20 +4774,105 @@
       </p:sp>
       <p:sp>
         <p:nvSpPr>
-          <p:cNvPr id="17" name="Rounded Rectangle 16"/>
+          <p:cNvPr id="38" name="Rounded Rectangle 37"/>
           <p:cNvSpPr/>
           <p:nvPr/>
         </p:nvSpPr>
         <p:spPr>
           <a:xfrm>
-            <a:off x="2758287" y="2240280"/>
-            <a:ext cx="2121408" cy="2331720"/>
+            <a:off x="3310128" y="4572000"/>
+            <a:ext cx="2057400" cy="502920"/>
           </a:xfrm>
           <a:prstGeom prst="roundRect">
             <a:avLst/>
           </a:prstGeom>
           <a:solidFill>
-            <a:srgbClr val="35C4AE"/>
+            <a:srgbClr val="182136"/>
+          </a:solidFill>
+          <a:ln w="22225">
+            <a:solidFill>
+              <a:srgbClr val="EAA83A"/>
+            </a:solidFill>
+          </a:ln>
+          <a:effectLst/>
+        </p:spPr>
+        <p:style>
+          <a:lnRef idx="1">
+            <a:schemeClr val="accent1"/>
+          </a:lnRef>
+          <a:fillRef idx="3">
+            <a:schemeClr val="accent1"/>
+          </a:fillRef>
+          <a:effectRef idx="2">
+            <a:schemeClr val="accent1"/>
+          </a:effectRef>
+          <a:fontRef idx="minor">
+            <a:schemeClr val="lt1"/>
+          </a:fontRef>
+        </p:style>
+        <p:txBody>
+          <a:bodyPr rtlCol="0" anchor="ctr"/>
+          <a:lstStyle/>
+          <a:p>
+            <a:pPr algn="ctr"/>
+          </a:p>
+        </p:txBody>
+      </p:sp>
+      <p:sp>
+        <p:nvSpPr>
+          <p:cNvPr id="39" name="TextBox 38"/>
+          <p:cNvSpPr txBox="1"/>
+          <p:nvPr/>
+        </p:nvSpPr>
+        <p:spPr>
+          <a:xfrm>
+            <a:off x="3310128" y="4572000"/>
+            <a:ext cx="2057400" cy="502920"/>
+          </a:xfrm>
+          <a:prstGeom prst="rect">
+            <a:avLst/>
+          </a:prstGeom>
+          <a:noFill/>
+        </p:spPr>
+        <p:txBody>
+          <a:bodyPr wrap="square" anchor="ctr">
+            <a:spAutoFit/>
+          </a:bodyPr>
+          <a:lstStyle/>
+          <a:p>
+            <a:pPr algn="ctr">
+              <a:spcAft>
+                <a:spcPts val="100"/>
+              </a:spcAft>
+            </a:pPr>
+            <a:r>
+              <a:rPr sz="1150" b="1">
+                <a:solidFill>
+                  <a:srgbClr val="EAA83A"/>
+                </a:solidFill>
+                <a:latin typeface="Calibri"/>
+              </a:rPr>
+              <a:t>IN_PROGRESS</a:t>
+            </a:r>
+          </a:p>
+        </p:txBody>
+      </p:sp>
+      <p:sp>
+        <p:nvSpPr>
+          <p:cNvPr id="40" name="Right Arrow 39"/>
+          <p:cNvSpPr/>
+          <p:nvPr/>
+        </p:nvSpPr>
+        <p:spPr>
+          <a:xfrm>
+            <a:off x="5413248" y="4750308"/>
+            <a:ext cx="292607" cy="146304"/>
+          </a:xfrm>
+          <a:prstGeom prst="rightArrow">
+            <a:avLst/>
+          </a:prstGeom>
+          <a:solidFill>
+            <a:srgbClr val="EAA83A"/>
           </a:solidFill>
           <a:ln>
             <a:noFill/>
@@ -3788,14 +4903,60 @@
       </p:sp>
       <p:sp>
         <p:nvSpPr>
-          <p:cNvPr id="18" name="TextBox 17"/>
+          <p:cNvPr id="41" name="Rounded Rectangle 40"/>
+          <p:cNvSpPr/>
+          <p:nvPr/>
+        </p:nvSpPr>
+        <p:spPr>
+          <a:xfrm>
+            <a:off x="5751576" y="4572000"/>
+            <a:ext cx="2057400" cy="502920"/>
+          </a:xfrm>
+          <a:prstGeom prst="roundRect">
+            <a:avLst/>
+          </a:prstGeom>
+          <a:solidFill>
+            <a:srgbClr val="182136"/>
+          </a:solidFill>
+          <a:ln w="22225">
+            <a:solidFill>
+              <a:srgbClr val="5A97F5"/>
+            </a:solidFill>
+          </a:ln>
+          <a:effectLst/>
+        </p:spPr>
+        <p:style>
+          <a:lnRef idx="1">
+            <a:schemeClr val="accent1"/>
+          </a:lnRef>
+          <a:fillRef idx="3">
+            <a:schemeClr val="accent1"/>
+          </a:fillRef>
+          <a:effectRef idx="2">
+            <a:schemeClr val="accent1"/>
+          </a:effectRef>
+          <a:fontRef idx="minor">
+            <a:schemeClr val="lt1"/>
+          </a:fontRef>
+        </p:style>
+        <p:txBody>
+          <a:bodyPr rtlCol="0" anchor="ctr"/>
+          <a:lstStyle/>
+          <a:p>
+            <a:pPr algn="ctr"/>
+          </a:p>
+        </p:txBody>
+      </p:sp>
+      <p:sp>
+        <p:nvSpPr>
+          <p:cNvPr id="42" name="TextBox 41"/>
           <p:cNvSpPr txBox="1"/>
           <p:nvPr/>
         </p:nvSpPr>
         <p:spPr>
           <a:xfrm>
-            <a:off x="2758287" y="2386584"/>
-            <a:ext cx="2121408" cy="274320"/>
+            <a:off x="5751576" y="4572000"/>
+            <a:ext cx="2057400" cy="502920"/>
           </a:xfrm>
           <a:prstGeom prst="rect">
             <a:avLst/>
@@ -3810,92 +4971,37 @@
           <a:p>
             <a:pPr algn="ctr">
               <a:spcAft>
-                <a:spcPts val="200"/>
+                <a:spcPts val="100"/>
               </a:spcAft>
             </a:pPr>
             <a:r>
-              <a:rPr sz="850" b="1">
-                <a:solidFill>
-                  <a:srgbClr val="0D1422"/>
+              <a:rPr sz="1150" b="1">
+                <a:solidFill>
+                  <a:srgbClr val="5A97F5"/>
                 </a:solidFill>
                 <a:latin typeface="Calibri"/>
               </a:rPr>
-              <a:t>◇ AI AGENT</a:t>
-            </a:r>
-          </a:p>
-        </p:txBody>
-      </p:sp>
-      <p:sp>
-        <p:nvSpPr>
-          <p:cNvPr id="19" name="TextBox 18"/>
-          <p:cNvSpPr txBox="1"/>
-          <p:nvPr/>
-        </p:nvSpPr>
-        <p:spPr>
-          <a:xfrm>
-            <a:off x="2758287" y="2679192"/>
-            <a:ext cx="2121408" cy="685800"/>
-          </a:xfrm>
-          <a:prstGeom prst="rect">
-            <a:avLst/>
-          </a:prstGeom>
-          <a:noFill/>
-        </p:spPr>
-        <p:txBody>
-          <a:bodyPr wrap="square" anchor="ctr">
-            <a:spAutoFit/>
-          </a:bodyPr>
-          <a:lstStyle/>
-          <a:p>
-            <a:pPr algn="ctr">
-              <a:spcAft>
-                <a:spcPts val="200"/>
-              </a:spcAft>
-            </a:pPr>
-            <a:r>
-              <a:rPr sz="1400" b="1">
-                <a:solidFill>
-                  <a:srgbClr val="0D1422"/>
-                </a:solidFill>
-                <a:latin typeface="Calibri"/>
-              </a:rPr>
-              <a:t>SSOT-AGENT</a:t>
-            </a:r>
-          </a:p>
-          <a:p>
-            <a:pPr algn="ctr">
-              <a:spcAft>
-                <a:spcPts val="200"/>
-              </a:spcAft>
-            </a:pPr>
-            <a:r>
-              <a:rPr sz="1100" b="0">
-                <a:solidFill>
-                  <a:srgbClr val="0D1422"/>
-                </a:solidFill>
-                <a:latin typeface="Calibri"/>
-              </a:rPr>
-              <a:t>spec generation</a:t>
-            </a:r>
-          </a:p>
-        </p:txBody>
-      </p:sp>
-      <p:sp>
-        <p:nvSpPr>
-          <p:cNvPr id="20" name="Rectangle 19"/>
+              <a:t>COMPLETED</a:t>
+            </a:r>
+          </a:p>
+        </p:txBody>
+      </p:sp>
+      <p:sp>
+        <p:nvSpPr>
+          <p:cNvPr id="43" name="Right Arrow 42"/>
           <p:cNvSpPr/>
           <p:nvPr/>
         </p:nvSpPr>
         <p:spPr>
           <a:xfrm>
-            <a:off x="3014319" y="3538728"/>
-            <a:ext cx="1609343" cy="12801"/>
-          </a:xfrm>
-          <a:prstGeom prst="rect">
+            <a:off x="7854696" y="4750308"/>
+            <a:ext cx="292607" cy="146304"/>
+          </a:xfrm>
+          <a:prstGeom prst="rightArrow">
             <a:avLst/>
           </a:prstGeom>
           <a:solidFill>
-            <a:srgbClr val="0D1422"/>
+            <a:srgbClr val="5A97F5"/>
           </a:solidFill>
           <a:ln>
             <a:noFill/>
@@ -3926,94 +5032,25 @@
       </p:sp>
       <p:sp>
         <p:nvSpPr>
-          <p:cNvPr id="21" name="TextBox 20"/>
-          <p:cNvSpPr txBox="1"/>
-          <p:nvPr/>
-        </p:nvSpPr>
-        <p:spPr>
-          <a:xfrm>
-            <a:off x="2959455" y="3611880"/>
-            <a:ext cx="1755648" cy="914400"/>
-          </a:xfrm>
-          <a:prstGeom prst="rect">
-            <a:avLst/>
-          </a:prstGeom>
-          <a:noFill/>
-        </p:spPr>
-        <p:txBody>
-          <a:bodyPr wrap="square" anchor="t">
-            <a:spAutoFit/>
-          </a:bodyPr>
-          <a:lstStyle/>
-          <a:p>
-            <a:pPr algn="l">
-              <a:spcAft>
-                <a:spcPts val="300"/>
-              </a:spcAft>
-            </a:pPr>
-            <a:r>
-              <a:rPr sz="900" b="0">
-                <a:solidFill>
-                  <a:srgbClr val="0D1422"/>
-                </a:solidFill>
-                <a:latin typeface="Calibri"/>
-              </a:rPr>
-              <a:t>▸ ssot-gen worker (LLM)</a:t>
-            </a:r>
-          </a:p>
-          <a:p>
-            <a:pPr algn="l">
-              <a:spcAft>
-                <a:spcPts val="300"/>
-              </a:spcAft>
-            </a:pPr>
-            <a:r>
-              <a:rPr sz="900" b="0">
-                <a:solidFill>
-                  <a:srgbClr val="0D1422"/>
-                </a:solidFill>
-                <a:latin typeface="Calibri"/>
-              </a:rPr>
-              <a:t>▸ verify_ssot.py</a:t>
-            </a:r>
-          </a:p>
-          <a:p>
-            <a:pPr algn="l">
-              <a:spcAft>
-                <a:spcPts val="300"/>
-              </a:spcAft>
-            </a:pPr>
-            <a:r>
-              <a:rPr sz="900" b="0">
-                <a:solidFill>
-                  <a:srgbClr val="0D1422"/>
-                </a:solidFill>
-                <a:latin typeface="Calibri"/>
-              </a:rPr>
-              <a:t>▸ check_ssot_disk.sh</a:t>
-            </a:r>
-          </a:p>
-        </p:txBody>
-      </p:sp>
-      <p:sp>
-        <p:nvSpPr>
-          <p:cNvPr id="22" name="Right Arrow 21"/>
+          <p:cNvPr id="44" name="Rounded Rectangle 43"/>
           <p:cNvSpPr/>
           <p:nvPr/>
         </p:nvSpPr>
         <p:spPr>
           <a:xfrm>
-            <a:off x="4870551" y="3314700"/>
-            <a:ext cx="274320" cy="182880"/>
-          </a:xfrm>
-          <a:prstGeom prst="rightArrow">
+            <a:off x="8193024" y="4572000"/>
+            <a:ext cx="2057400" cy="502920"/>
+          </a:xfrm>
+          <a:prstGeom prst="roundRect">
             <a:avLst/>
           </a:prstGeom>
           <a:solidFill>
-            <a:srgbClr val="35C4AE"/>
+            <a:srgbClr val="182136"/>
           </a:solidFill>
-          <a:ln>
-            <a:noFill/>
+          <a:ln w="22225">
+            <a:solidFill>
+              <a:srgbClr val="4FC284"/>
+            </a:solidFill>
           </a:ln>
           <a:effectLst/>
         </p:spPr>
@@ -4041,60 +5078,14 @@
       </p:sp>
       <p:sp>
         <p:nvSpPr>
-          <p:cNvPr id="23" name="Document 22"/>
-          <p:cNvSpPr/>
-          <p:nvPr/>
-        </p:nvSpPr>
-        <p:spPr>
-          <a:xfrm>
-            <a:off x="5080863" y="2240280"/>
-            <a:ext cx="2212848" cy="2423160"/>
-          </a:xfrm>
-          <a:prstGeom prst="flowChartDocument">
-            <a:avLst/>
-          </a:prstGeom>
-          <a:solidFill>
-            <a:srgbClr val="182136"/>
-          </a:solidFill>
-          <a:ln w="28575">
-            <a:solidFill>
-              <a:srgbClr val="35C4AE"/>
-            </a:solidFill>
-          </a:ln>
-          <a:effectLst/>
-        </p:spPr>
-        <p:style>
-          <a:lnRef idx="1">
-            <a:schemeClr val="accent1"/>
-          </a:lnRef>
-          <a:fillRef idx="3">
-            <a:schemeClr val="accent1"/>
-          </a:fillRef>
-          <a:effectRef idx="2">
-            <a:schemeClr val="accent1"/>
-          </a:effectRef>
-          <a:fontRef idx="minor">
-            <a:schemeClr val="lt1"/>
-          </a:fontRef>
-        </p:style>
-        <p:txBody>
-          <a:bodyPr rtlCol="0" anchor="ctr"/>
-          <a:lstStyle/>
-          <a:p>
-            <a:pPr algn="ctr"/>
-          </a:p>
-        </p:txBody>
-      </p:sp>
-      <p:sp>
-        <p:nvSpPr>
-          <p:cNvPr id="24" name="TextBox 23"/>
+          <p:cNvPr id="45" name="TextBox 44"/>
           <p:cNvSpPr txBox="1"/>
           <p:nvPr/>
         </p:nvSpPr>
         <p:spPr>
           <a:xfrm>
-            <a:off x="5080863" y="2404872"/>
-            <a:ext cx="2212848" cy="274320"/>
+            <a:off x="8193024" y="4572000"/>
+            <a:ext cx="2057400" cy="502920"/>
           </a:xfrm>
           <a:prstGeom prst="rect">
             <a:avLst/>
@@ -4109,31 +5100,31 @@
           <a:p>
             <a:pPr algn="ctr">
               <a:spcAft>
-                <a:spcPts val="200"/>
+                <a:spcPts val="100"/>
               </a:spcAft>
             </a:pPr>
             <a:r>
-              <a:rPr sz="900" b="1">
-                <a:solidFill>
-                  <a:srgbClr val="35C4AE"/>
+              <a:rPr sz="1150" b="1">
+                <a:solidFill>
+                  <a:srgbClr val="4FC284"/>
                 </a:solidFill>
                 <a:latin typeface="Calibri"/>
               </a:rPr>
-              <a:t>OUTPUT</a:t>
-            </a:r>
-          </a:p>
-        </p:txBody>
-      </p:sp>
-      <p:sp>
-        <p:nvSpPr>
-          <p:cNvPr id="25" name="TextBox 24"/>
+              <a:t>APPROVED ✓</a:t>
+            </a:r>
+          </a:p>
+        </p:txBody>
+      </p:sp>
+      <p:sp>
+        <p:nvSpPr>
+          <p:cNvPr id="46" name="TextBox 45"/>
           <p:cNvSpPr txBox="1"/>
           <p:nvPr/>
         </p:nvSpPr>
         <p:spPr>
           <a:xfrm>
-            <a:off x="5080863" y="2697480"/>
-            <a:ext cx="2212848" cy="457200"/>
+            <a:off x="10680192" y="4572000"/>
+            <a:ext cx="2651760" cy="502920"/>
           </a:xfrm>
           <a:prstGeom prst="rect">
             <a:avLst/>
@@ -4146,33 +5137,88 @@
           </a:bodyPr>
           <a:lstStyle/>
           <a:p>
-            <a:pPr algn="ctr">
+            <a:pPr algn="l">
               <a:spcAft>
-                <a:spcPts val="200"/>
+                <a:spcPts val="100"/>
               </a:spcAft>
             </a:pPr>
             <a:r>
-              <a:rPr sz="1700" b="1">
-                <a:solidFill>
-                  <a:srgbClr val="35C4AE"/>
+              <a:rPr sz="950" b="1">
+                <a:solidFill>
+                  <a:srgbClr val="D95A4F"/>
                 </a:solidFill>
                 <a:latin typeface="Calibri"/>
               </a:rPr>
-              <a:t>SSOT</a:t>
-            </a:r>
-          </a:p>
-        </p:txBody>
-      </p:sp>
-      <p:sp>
-        <p:nvSpPr>
-          <p:cNvPr id="26" name="Rectangle 25"/>
+              <a:t>↩ rejected · ⏸ blocked</a:t>
+            </a:r>
+          </a:p>
+          <a:p>
+            <a:pPr algn="l">
+              <a:spcAft>
+                <a:spcPts val="100"/>
+              </a:spcAft>
+            </a:pPr>
+            <a:r>
+              <a:rPr sz="850" b="0">
+                <a:solidFill>
+                  <a:srgbClr val="6B7995"/>
+                </a:solidFill>
+                <a:latin typeface="Calibri"/>
+              </a:rPr>
+              <a:t>→ todo_events ledger</a:t>
+            </a:r>
+          </a:p>
+        </p:txBody>
+      </p:sp>
+      <p:sp>
+        <p:nvSpPr>
+          <p:cNvPr id="47" name="TextBox 46"/>
+          <p:cNvSpPr txBox="1"/>
+          <p:nvPr/>
+        </p:nvSpPr>
+        <p:spPr>
+          <a:xfrm>
+            <a:off x="731520" y="5138928"/>
+            <a:ext cx="11430000" cy="237744"/>
+          </a:xfrm>
+          <a:prstGeom prst="rect">
+            <a:avLst/>
+          </a:prstGeom>
+          <a:noFill/>
+        </p:spPr>
+        <p:txBody>
+          <a:bodyPr wrap="square" anchor="t">
+            <a:spAutoFit/>
+          </a:bodyPr>
+          <a:lstStyle/>
+          <a:p>
+            <a:pPr algn="l">
+              <a:spcAft>
+                <a:spcPts val="100"/>
+              </a:spcAft>
+            </a:pPr>
+            <a:r>
+              <a:rPr sz="850" b="0">
+                <a:solidFill>
+                  <a:srgbClr val="6B7995"/>
+                </a:solidFill>
+                <a:latin typeface="Calibri"/>
+              </a:rPr>
+              <a:t>derived from SSOT (golden todos) &amp; RTL gaps (derive_rtl_todos.py) · stored in workflow_todos + todo.json</a:t>
+            </a:r>
+          </a:p>
+        </p:txBody>
+      </p:sp>
+      <p:sp>
+        <p:nvSpPr>
+          <p:cNvPr id="48" name="Rectangle 47"/>
           <p:cNvSpPr/>
           <p:nvPr/>
         </p:nvSpPr>
         <p:spPr>
           <a:xfrm>
-            <a:off x="5336895" y="3429000"/>
-            <a:ext cx="1700784" cy="10972"/>
+            <a:off x="0" y="5468112"/>
+            <a:ext cx="12191695" cy="9144"/>
           </a:xfrm>
           <a:prstGeom prst="rect">
             <a:avLst/>
@@ -4209,14 +5255,14 @@
       </p:sp>
       <p:sp>
         <p:nvSpPr>
-          <p:cNvPr id="27" name="TextBox 26"/>
+          <p:cNvPr id="49" name="TextBox 48"/>
           <p:cNvSpPr txBox="1"/>
           <p:nvPr/>
         </p:nvSpPr>
         <p:spPr>
           <a:xfrm>
-            <a:off x="5282031" y="3520440"/>
-            <a:ext cx="1847088" cy="914400"/>
+            <a:off x="713232" y="5522976"/>
+            <a:ext cx="10972800" cy="237744"/>
           </a:xfrm>
           <a:prstGeom prst="rect">
             <a:avLst/>
@@ -4231,706 +5277,11 @@
           <a:p>
             <a:pPr algn="l">
               <a:spcAft>
-                <a:spcPts val="300"/>
+                <a:spcPts val="100"/>
               </a:spcAft>
             </a:pPr>
             <a:r>
-              <a:rPr sz="900" b="0">
-                <a:solidFill>
-                  <a:srgbClr val="9AAAC6"/>
-                </a:solidFill>
-                <a:latin typeface="Calibri"/>
-              </a:rPr>
-              <a:t>▸ &lt;ip&gt;.ssot.yaml</a:t>
-            </a:r>
-          </a:p>
-          <a:p>
-            <a:pPr algn="l">
-              <a:spcAft>
-                <a:spcPts val="300"/>
-              </a:spcAft>
-            </a:pPr>
-            <a:r>
-              <a:rPr sz="900" b="0">
-                <a:solidFill>
-                  <a:srgbClr val="9AAAC6"/>
-                </a:solidFill>
-                <a:latin typeface="Calibri"/>
-              </a:rPr>
-              <a:t>▸ standard spec, 20 sections</a:t>
-            </a:r>
-          </a:p>
-          <a:p>
-            <a:pPr algn="l">
-              <a:spcAft>
-                <a:spcPts val="300"/>
-              </a:spcAft>
-            </a:pPr>
-            <a:r>
-              <a:rPr sz="900" b="0">
-                <a:solidFill>
-                  <a:srgbClr val="9AAAC6"/>
-                </a:solidFill>
-                <a:latin typeface="Calibri"/>
-              </a:rPr>
-              <a:t>▸ io / function_model ...</a:t>
-            </a:r>
-          </a:p>
-        </p:txBody>
-      </p:sp>
-      <p:sp>
-        <p:nvSpPr>
-          <p:cNvPr id="28" name="Right Arrow 27"/>
-          <p:cNvSpPr/>
-          <p:nvPr/>
-        </p:nvSpPr>
-        <p:spPr>
-          <a:xfrm>
-            <a:off x="7284567" y="3314700"/>
-            <a:ext cx="274320" cy="182880"/>
-          </a:xfrm>
-          <a:prstGeom prst="rightArrow">
-            <a:avLst/>
-          </a:prstGeom>
-          <a:solidFill>
-            <a:srgbClr val="6B7995"/>
-          </a:solidFill>
-          <a:ln>
-            <a:noFill/>
-          </a:ln>
-          <a:effectLst/>
-        </p:spPr>
-        <p:style>
-          <a:lnRef idx="1">
-            <a:schemeClr val="accent1"/>
-          </a:lnRef>
-          <a:fillRef idx="3">
-            <a:schemeClr val="accent1"/>
-          </a:fillRef>
-          <a:effectRef idx="2">
-            <a:schemeClr val="accent1"/>
-          </a:effectRef>
-          <a:fontRef idx="minor">
-            <a:schemeClr val="lt1"/>
-          </a:fontRef>
-        </p:style>
-        <p:txBody>
-          <a:bodyPr rtlCol="0" anchor="ctr"/>
-          <a:lstStyle/>
-          <a:p>
-            <a:pPr algn="ctr"/>
-          </a:p>
-        </p:txBody>
-      </p:sp>
-      <p:sp>
-        <p:nvSpPr>
-          <p:cNvPr id="29" name="Rounded Rectangle 28"/>
-          <p:cNvSpPr/>
-          <p:nvPr/>
-        </p:nvSpPr>
-        <p:spPr>
-          <a:xfrm>
-            <a:off x="7494879" y="2240280"/>
-            <a:ext cx="2121408" cy="2331720"/>
-          </a:xfrm>
-          <a:prstGeom prst="roundRect">
-            <a:avLst/>
-          </a:prstGeom>
-          <a:solidFill>
-            <a:srgbClr val="EAA83A"/>
-          </a:solidFill>
-          <a:ln>
-            <a:noFill/>
-          </a:ln>
-          <a:effectLst/>
-        </p:spPr>
-        <p:style>
-          <a:lnRef idx="1">
-            <a:schemeClr val="accent1"/>
-          </a:lnRef>
-          <a:fillRef idx="3">
-            <a:schemeClr val="accent1"/>
-          </a:fillRef>
-          <a:effectRef idx="2">
-            <a:schemeClr val="accent1"/>
-          </a:effectRef>
-          <a:fontRef idx="minor">
-            <a:schemeClr val="lt1"/>
-          </a:fontRef>
-        </p:style>
-        <p:txBody>
-          <a:bodyPr rtlCol="0" anchor="ctr"/>
-          <a:lstStyle/>
-          <a:p>
-            <a:pPr algn="ctr"/>
-          </a:p>
-        </p:txBody>
-      </p:sp>
-      <p:sp>
-        <p:nvSpPr>
-          <p:cNvPr id="30" name="TextBox 29"/>
-          <p:cNvSpPr txBox="1"/>
-          <p:nvPr/>
-        </p:nvSpPr>
-        <p:spPr>
-          <a:xfrm>
-            <a:off x="7494879" y="2386584"/>
-            <a:ext cx="2121408" cy="274320"/>
-          </a:xfrm>
-          <a:prstGeom prst="rect">
-            <a:avLst/>
-          </a:prstGeom>
-          <a:noFill/>
-        </p:spPr>
-        <p:txBody>
-          <a:bodyPr wrap="square" anchor="ctr">
-            <a:spAutoFit/>
-          </a:bodyPr>
-          <a:lstStyle/>
-          <a:p>
-            <a:pPr algn="ctr">
-              <a:spcAft>
-                <a:spcPts val="200"/>
-              </a:spcAft>
-            </a:pPr>
-            <a:r>
-              <a:rPr sz="850" b="1">
-                <a:solidFill>
-                  <a:srgbClr val="0D1422"/>
-                </a:solidFill>
-                <a:latin typeface="Calibri"/>
-              </a:rPr>
-              <a:t>◇ AI AGENT</a:t>
-            </a:r>
-          </a:p>
-        </p:txBody>
-      </p:sp>
-      <p:sp>
-        <p:nvSpPr>
-          <p:cNvPr id="31" name="TextBox 30"/>
-          <p:cNvSpPr txBox="1"/>
-          <p:nvPr/>
-        </p:nvSpPr>
-        <p:spPr>
-          <a:xfrm>
-            <a:off x="7494879" y="2679192"/>
-            <a:ext cx="2121408" cy="685800"/>
-          </a:xfrm>
-          <a:prstGeom prst="rect">
-            <a:avLst/>
-          </a:prstGeom>
-          <a:noFill/>
-        </p:spPr>
-        <p:txBody>
-          <a:bodyPr wrap="square" anchor="ctr">
-            <a:spAutoFit/>
-          </a:bodyPr>
-          <a:lstStyle/>
-          <a:p>
-            <a:pPr algn="ctr">
-              <a:spcAft>
-                <a:spcPts val="200"/>
-              </a:spcAft>
-            </a:pPr>
-            <a:r>
-              <a:rPr sz="1400" b="1">
-                <a:solidFill>
-                  <a:srgbClr val="0D1422"/>
-                </a:solidFill>
-                <a:latin typeface="Calibri"/>
-              </a:rPr>
-              <a:t>RTL-AGENT</a:t>
-            </a:r>
-          </a:p>
-          <a:p>
-            <a:pPr algn="ctr">
-              <a:spcAft>
-                <a:spcPts val="200"/>
-              </a:spcAft>
-            </a:pPr>
-            <a:r>
-              <a:rPr sz="1100" b="0">
-                <a:solidFill>
-                  <a:srgbClr val="0D1422"/>
-                </a:solidFill>
-                <a:latin typeface="Calibri"/>
-              </a:rPr>
-              <a:t>RTL generation</a:t>
-            </a:r>
-          </a:p>
-        </p:txBody>
-      </p:sp>
-      <p:sp>
-        <p:nvSpPr>
-          <p:cNvPr id="32" name="Rectangle 31"/>
-          <p:cNvSpPr/>
-          <p:nvPr/>
-        </p:nvSpPr>
-        <p:spPr>
-          <a:xfrm>
-            <a:off x="7750911" y="3538728"/>
-            <a:ext cx="1609343" cy="12801"/>
-          </a:xfrm>
-          <a:prstGeom prst="rect">
-            <a:avLst/>
-          </a:prstGeom>
-          <a:solidFill>
-            <a:srgbClr val="0D1422"/>
-          </a:solidFill>
-          <a:ln>
-            <a:noFill/>
-          </a:ln>
-          <a:effectLst/>
-        </p:spPr>
-        <p:style>
-          <a:lnRef idx="1">
-            <a:schemeClr val="accent1"/>
-          </a:lnRef>
-          <a:fillRef idx="3">
-            <a:schemeClr val="accent1"/>
-          </a:fillRef>
-          <a:effectRef idx="2">
-            <a:schemeClr val="accent1"/>
-          </a:effectRef>
-          <a:fontRef idx="minor">
-            <a:schemeClr val="lt1"/>
-          </a:fontRef>
-        </p:style>
-        <p:txBody>
-          <a:bodyPr rtlCol="0" anchor="ctr"/>
-          <a:lstStyle/>
-          <a:p>
-            <a:pPr algn="ctr"/>
-          </a:p>
-        </p:txBody>
-      </p:sp>
-      <p:sp>
-        <p:nvSpPr>
-          <p:cNvPr id="33" name="TextBox 32"/>
-          <p:cNvSpPr txBox="1"/>
-          <p:nvPr/>
-        </p:nvSpPr>
-        <p:spPr>
-          <a:xfrm>
-            <a:off x="7696047" y="3611880"/>
-            <a:ext cx="1755648" cy="914400"/>
-          </a:xfrm>
-          <a:prstGeom prst="rect">
-            <a:avLst/>
-          </a:prstGeom>
-          <a:noFill/>
-        </p:spPr>
-        <p:txBody>
-          <a:bodyPr wrap="square" anchor="t">
-            <a:spAutoFit/>
-          </a:bodyPr>
-          <a:lstStyle/>
-          <a:p>
-            <a:pPr algn="l">
-              <a:spcAft>
-                <a:spcPts val="300"/>
-              </a:spcAft>
-            </a:pPr>
-            <a:r>
-              <a:rPr sz="900" b="0">
-                <a:solidFill>
-                  <a:srgbClr val="0D1422"/>
-                </a:solidFill>
-                <a:latin typeface="Calibri"/>
-              </a:rPr>
-              <a:t>▸ ssot_to_rtl.py (LLM)</a:t>
-            </a:r>
-          </a:p>
-          <a:p>
-            <a:pPr algn="l">
-              <a:spcAft>
-                <a:spcPts val="300"/>
-              </a:spcAft>
-            </a:pPr>
-            <a:r>
-              <a:rPr sz="900" b="0">
-                <a:solidFill>
-                  <a:srgbClr val="0D1422"/>
-                </a:solidFill>
-                <a:latin typeface="Calibri"/>
-              </a:rPr>
-              <a:t>▸ rtl_compile_report.py</a:t>
-            </a:r>
-          </a:p>
-          <a:p>
-            <a:pPr algn="l">
-              <a:spcAft>
-                <a:spcPts val="300"/>
-              </a:spcAft>
-            </a:pPr>
-            <a:r>
-              <a:rPr sz="900" b="0">
-                <a:solidFill>
-                  <a:srgbClr val="0D1422"/>
-                </a:solidFill>
-                <a:latin typeface="Calibri"/>
-              </a:rPr>
-              <a:t>▸ build_gate.sh</a:t>
-            </a:r>
-          </a:p>
-        </p:txBody>
-      </p:sp>
-      <p:sp>
-        <p:nvSpPr>
-          <p:cNvPr id="34" name="Right Arrow 33"/>
-          <p:cNvSpPr/>
-          <p:nvPr/>
-        </p:nvSpPr>
-        <p:spPr>
-          <a:xfrm>
-            <a:off x="9607143" y="3314700"/>
-            <a:ext cx="274320" cy="182880"/>
-          </a:xfrm>
-          <a:prstGeom prst="rightArrow">
-            <a:avLst/>
-          </a:prstGeom>
-          <a:solidFill>
-            <a:srgbClr val="EAA83A"/>
-          </a:solidFill>
-          <a:ln>
-            <a:noFill/>
-          </a:ln>
-          <a:effectLst/>
-        </p:spPr>
-        <p:style>
-          <a:lnRef idx="1">
-            <a:schemeClr val="accent1"/>
-          </a:lnRef>
-          <a:fillRef idx="3">
-            <a:schemeClr val="accent1"/>
-          </a:fillRef>
-          <a:effectRef idx="2">
-            <a:schemeClr val="accent1"/>
-          </a:effectRef>
-          <a:fontRef idx="minor">
-            <a:schemeClr val="lt1"/>
-          </a:fontRef>
-        </p:style>
-        <p:txBody>
-          <a:bodyPr rtlCol="0" anchor="ctr"/>
-          <a:lstStyle/>
-          <a:p>
-            <a:pPr algn="ctr"/>
-          </a:p>
-        </p:txBody>
-      </p:sp>
-      <p:sp>
-        <p:nvSpPr>
-          <p:cNvPr id="35" name="Document 34"/>
-          <p:cNvSpPr/>
-          <p:nvPr/>
-        </p:nvSpPr>
-        <p:spPr>
-          <a:xfrm>
-            <a:off x="9817455" y="2240280"/>
-            <a:ext cx="2212848" cy="2423160"/>
-          </a:xfrm>
-          <a:prstGeom prst="flowChartDocument">
-            <a:avLst/>
-          </a:prstGeom>
-          <a:solidFill>
-            <a:srgbClr val="182136"/>
-          </a:solidFill>
-          <a:ln w="28575">
-            <a:solidFill>
-              <a:srgbClr val="EAA83A"/>
-            </a:solidFill>
-          </a:ln>
-          <a:effectLst/>
-        </p:spPr>
-        <p:style>
-          <a:lnRef idx="1">
-            <a:schemeClr val="accent1"/>
-          </a:lnRef>
-          <a:fillRef idx="3">
-            <a:schemeClr val="accent1"/>
-          </a:fillRef>
-          <a:effectRef idx="2">
-            <a:schemeClr val="accent1"/>
-          </a:effectRef>
-          <a:fontRef idx="minor">
-            <a:schemeClr val="lt1"/>
-          </a:fontRef>
-        </p:style>
-        <p:txBody>
-          <a:bodyPr rtlCol="0" anchor="ctr"/>
-          <a:lstStyle/>
-          <a:p>
-            <a:pPr algn="ctr"/>
-          </a:p>
-        </p:txBody>
-      </p:sp>
-      <p:sp>
-        <p:nvSpPr>
-          <p:cNvPr id="36" name="TextBox 35"/>
-          <p:cNvSpPr txBox="1"/>
-          <p:nvPr/>
-        </p:nvSpPr>
-        <p:spPr>
-          <a:xfrm>
-            <a:off x="9817455" y="2404872"/>
-            <a:ext cx="2212848" cy="274320"/>
-          </a:xfrm>
-          <a:prstGeom prst="rect">
-            <a:avLst/>
-          </a:prstGeom>
-          <a:noFill/>
-        </p:spPr>
-        <p:txBody>
-          <a:bodyPr wrap="square" anchor="ctr">
-            <a:spAutoFit/>
-          </a:bodyPr>
-          <a:lstStyle/>
-          <a:p>
-            <a:pPr algn="ctr">
-              <a:spcAft>
-                <a:spcPts val="200"/>
-              </a:spcAft>
-            </a:pPr>
-            <a:r>
-              <a:rPr sz="900" b="1">
-                <a:solidFill>
-                  <a:srgbClr val="EAA83A"/>
-                </a:solidFill>
-                <a:latin typeface="Calibri"/>
-              </a:rPr>
-              <a:t>OUTPUT</a:t>
-            </a:r>
-          </a:p>
-        </p:txBody>
-      </p:sp>
-      <p:sp>
-        <p:nvSpPr>
-          <p:cNvPr id="37" name="TextBox 36"/>
-          <p:cNvSpPr txBox="1"/>
-          <p:nvPr/>
-        </p:nvSpPr>
-        <p:spPr>
-          <a:xfrm>
-            <a:off x="9817455" y="2697480"/>
-            <a:ext cx="2212848" cy="457200"/>
-          </a:xfrm>
-          <a:prstGeom prst="rect">
-            <a:avLst/>
-          </a:prstGeom>
-          <a:noFill/>
-        </p:spPr>
-        <p:txBody>
-          <a:bodyPr wrap="square" anchor="ctr">
-            <a:spAutoFit/>
-          </a:bodyPr>
-          <a:lstStyle/>
-          <a:p>
-            <a:pPr algn="ctr">
-              <a:spcAft>
-                <a:spcPts val="200"/>
-              </a:spcAft>
-            </a:pPr>
-            <a:r>
-              <a:rPr sz="1700" b="1">
-                <a:solidFill>
-                  <a:srgbClr val="EAA83A"/>
-                </a:solidFill>
-                <a:latin typeface="Calibri"/>
-              </a:rPr>
-              <a:t>RTL</a:t>
-            </a:r>
-          </a:p>
-        </p:txBody>
-      </p:sp>
-      <p:sp>
-        <p:nvSpPr>
-          <p:cNvPr id="38" name="Rectangle 37"/>
-          <p:cNvSpPr/>
-          <p:nvPr/>
-        </p:nvSpPr>
-        <p:spPr>
-          <a:xfrm>
-            <a:off x="10073487" y="3429000"/>
-            <a:ext cx="1700784" cy="10972"/>
-          </a:xfrm>
-          <a:prstGeom prst="rect">
-            <a:avLst/>
-          </a:prstGeom>
-          <a:solidFill>
-            <a:srgbClr val="2B3852"/>
-          </a:solidFill>
-          <a:ln>
-            <a:noFill/>
-          </a:ln>
-          <a:effectLst/>
-        </p:spPr>
-        <p:style>
-          <a:lnRef idx="1">
-            <a:schemeClr val="accent1"/>
-          </a:lnRef>
-          <a:fillRef idx="3">
-            <a:schemeClr val="accent1"/>
-          </a:fillRef>
-          <a:effectRef idx="2">
-            <a:schemeClr val="accent1"/>
-          </a:effectRef>
-          <a:fontRef idx="minor">
-            <a:schemeClr val="lt1"/>
-          </a:fontRef>
-        </p:style>
-        <p:txBody>
-          <a:bodyPr rtlCol="0" anchor="ctr"/>
-          <a:lstStyle/>
-          <a:p>
-            <a:pPr algn="ctr"/>
-          </a:p>
-        </p:txBody>
-      </p:sp>
-      <p:sp>
-        <p:nvSpPr>
-          <p:cNvPr id="39" name="TextBox 38"/>
-          <p:cNvSpPr txBox="1"/>
-          <p:nvPr/>
-        </p:nvSpPr>
-        <p:spPr>
-          <a:xfrm>
-            <a:off x="10018623" y="3520440"/>
-            <a:ext cx="1847088" cy="914400"/>
-          </a:xfrm>
-          <a:prstGeom prst="rect">
-            <a:avLst/>
-          </a:prstGeom>
-          <a:noFill/>
-        </p:spPr>
-        <p:txBody>
-          <a:bodyPr wrap="square" anchor="t">
-            <a:spAutoFit/>
-          </a:bodyPr>
-          <a:lstStyle/>
-          <a:p>
-            <a:pPr algn="l">
-              <a:spcAft>
-                <a:spcPts val="300"/>
-              </a:spcAft>
-            </a:pPr>
-            <a:r>
-              <a:rPr sz="900" b="0">
-                <a:solidFill>
-                  <a:srgbClr val="9AAAC6"/>
-                </a:solidFill>
-                <a:latin typeface="Calibri"/>
-              </a:rPr>
-              <a:t>▸ &lt;ip&gt;.sv (implementation)</a:t>
-            </a:r>
-          </a:p>
-          <a:p>
-            <a:pPr algn="l">
-              <a:spcAft>
-                <a:spcPts val="300"/>
-              </a:spcAft>
-            </a:pPr>
-            <a:r>
-              <a:rPr sz="900" b="0">
-                <a:solidFill>
-                  <a:srgbClr val="9AAAC6"/>
-                </a:solidFill>
-                <a:latin typeface="Calibri"/>
-              </a:rPr>
-              <a:t>▸ list/&lt;ip&gt;.f</a:t>
-            </a:r>
-          </a:p>
-          <a:p>
-            <a:pPr algn="l">
-              <a:spcAft>
-                <a:spcPts val="300"/>
-              </a:spcAft>
-            </a:pPr>
-            <a:r>
-              <a:rPr sz="900" b="0">
-                <a:solidFill>
-                  <a:srgbClr val="9AAAC6"/>
-                </a:solidFill>
-                <a:latin typeface="Calibri"/>
-              </a:rPr>
-              <a:t>▸ rtl_compile.json</a:t>
-            </a:r>
-          </a:p>
-        </p:txBody>
-      </p:sp>
-      <p:sp>
-        <p:nvSpPr>
-          <p:cNvPr id="40" name="Rectangle 39"/>
-          <p:cNvSpPr/>
-          <p:nvPr/>
-        </p:nvSpPr>
-        <p:spPr>
-          <a:xfrm>
-            <a:off x="0" y="4828032"/>
-            <a:ext cx="12191695" cy="10972"/>
-          </a:xfrm>
-          <a:prstGeom prst="rect">
-            <a:avLst/>
-          </a:prstGeom>
-          <a:solidFill>
-            <a:srgbClr val="2B3852"/>
-          </a:solidFill>
-          <a:ln>
-            <a:noFill/>
-          </a:ln>
-          <a:effectLst/>
-        </p:spPr>
-        <p:style>
-          <a:lnRef idx="1">
-            <a:schemeClr val="accent1"/>
-          </a:lnRef>
-          <a:fillRef idx="3">
-            <a:schemeClr val="accent1"/>
-          </a:fillRef>
-          <a:effectRef idx="2">
-            <a:schemeClr val="accent1"/>
-          </a:effectRef>
-          <a:fontRef idx="minor">
-            <a:schemeClr val="lt1"/>
-          </a:fontRef>
-        </p:style>
-        <p:txBody>
-          <a:bodyPr rtlCol="0" anchor="ctr"/>
-          <a:lstStyle/>
-          <a:p>
-            <a:pPr algn="ctr"/>
-          </a:p>
-        </p:txBody>
-      </p:sp>
-      <p:sp>
-        <p:nvSpPr>
-          <p:cNvPr id="41" name="TextBox 40"/>
-          <p:cNvSpPr txBox="1"/>
-          <p:nvPr/>
-        </p:nvSpPr>
-        <p:spPr>
-          <a:xfrm>
-            <a:off x="713232" y="4901184"/>
-            <a:ext cx="10972800" cy="292608"/>
-          </a:xfrm>
-          <a:prstGeom prst="rect">
-            <a:avLst/>
-          </a:prstGeom>
-          <a:noFill/>
-        </p:spPr>
-        <p:txBody>
-          <a:bodyPr wrap="square" anchor="t">
-            <a:spAutoFit/>
-          </a:bodyPr>
-          <a:lstStyle/>
-          <a:p>
-            <a:pPr algn="l">
-              <a:spcAft>
-                <a:spcPts val="200"/>
-              </a:spcAft>
-            </a:pPr>
-            <a:r>
-              <a:rPr sz="1300" b="1">
+              <a:rPr sz="1100" b="1">
                 <a:solidFill>
                   <a:srgbClr val="9AAAC6"/>
                 </a:solidFill>
@@ -4943,14 +5294,14 @@
       </p:sp>
       <p:sp>
         <p:nvSpPr>
-          <p:cNvPr id="42" name="Rounded Rectangle 41"/>
+          <p:cNvPr id="50" name="Rounded Rectangle 49"/>
           <p:cNvSpPr/>
           <p:nvPr/>
         </p:nvSpPr>
         <p:spPr>
           <a:xfrm>
-            <a:off x="303123" y="5285232"/>
-            <a:ext cx="2724912" cy="1280160"/>
+            <a:off x="303123" y="5806440"/>
+            <a:ext cx="2724912" cy="777240"/>
           </a:xfrm>
           <a:prstGeom prst="roundRect">
             <a:avLst/>
@@ -4989,14 +5340,14 @@
       </p:sp>
       <p:sp>
         <p:nvSpPr>
-          <p:cNvPr id="43" name="Rectangle 42"/>
+          <p:cNvPr id="51" name="Rectangle 50"/>
           <p:cNvSpPr/>
           <p:nvPr/>
         </p:nvSpPr>
         <p:spPr>
           <a:xfrm>
-            <a:off x="303123" y="5285232"/>
-            <a:ext cx="91440" cy="1280160"/>
+            <a:off x="303123" y="5806440"/>
+            <a:ext cx="82296" cy="777240"/>
           </a:xfrm>
           <a:prstGeom prst="rect">
             <a:avLst/>
@@ -5033,14 +5384,14 @@
       </p:sp>
       <p:sp>
         <p:nvSpPr>
-          <p:cNvPr id="44" name="TextBox 43"/>
+          <p:cNvPr id="52" name="TextBox 51"/>
           <p:cNvSpPr txBox="1"/>
           <p:nvPr/>
         </p:nvSpPr>
         <p:spPr>
           <a:xfrm>
-            <a:off x="577443" y="5431536"/>
-            <a:ext cx="2313432" cy="365760"/>
+            <a:off x="540867" y="5897879"/>
+            <a:ext cx="2359152" cy="292608"/>
           </a:xfrm>
           <a:prstGeom prst="rect">
             <a:avLst/>
@@ -5055,11 +5406,11 @@
           <a:p>
             <a:pPr algn="l">
               <a:spcAft>
-                <a:spcPts val="200"/>
+                <a:spcPts val="100"/>
               </a:spcAft>
             </a:pPr>
             <a:r>
-              <a:rPr sz="1250" b="1">
+              <a:rPr sz="1100" b="1">
                 <a:solidFill>
                   <a:srgbClr val="35C4AE"/>
                 </a:solidFill>
@@ -5072,14 +5423,14 @@
       </p:sp>
       <p:sp>
         <p:nvSpPr>
-          <p:cNvPr id="45" name="TextBox 44"/>
+          <p:cNvPr id="53" name="TextBox 52"/>
           <p:cNvSpPr txBox="1"/>
           <p:nvPr/>
         </p:nvSpPr>
         <p:spPr>
           <a:xfrm>
-            <a:off x="577443" y="5815584"/>
-            <a:ext cx="2267712" cy="685800"/>
+            <a:off x="540867" y="6190488"/>
+            <a:ext cx="2340864" cy="365760"/>
           </a:xfrm>
           <a:prstGeom prst="rect">
             <a:avLst/>
@@ -5094,32 +5445,31 @@
           <a:p>
             <a:pPr algn="l">
               <a:spcAft>
-                <a:spcPts val="200"/>
+                <a:spcPts val="100"/>
               </a:spcAft>
             </a:pPr>
             <a:r>
-              <a:rPr sz="950" b="0">
+              <a:rPr sz="900" b="0">
                 <a:solidFill>
                   <a:srgbClr val="9AAAC6"/>
                 </a:solidFill>
                 <a:latin typeface="Calibri"/>
               </a:rPr>
-              <a:t>Automates spec &amp; RTL authoring,
-cutting repetitive engineering time</a:t>
-            </a:r>
-          </a:p>
-        </p:txBody>
-      </p:sp>
-      <p:sp>
-        <p:nvSpPr>
-          <p:cNvPr id="46" name="Rounded Rectangle 45"/>
+              <a:t>spec &amp; RTL authoring automated</a:t>
+            </a:r>
+          </a:p>
+        </p:txBody>
+      </p:sp>
+      <p:sp>
+        <p:nvSpPr>
+          <p:cNvPr id="54" name="Rounded Rectangle 53"/>
           <p:cNvSpPr/>
           <p:nvPr/>
         </p:nvSpPr>
         <p:spPr>
           <a:xfrm>
-            <a:off x="3256635" y="5285232"/>
-            <a:ext cx="2724912" cy="1280160"/>
+            <a:off x="3256635" y="5806440"/>
+            <a:ext cx="2724912" cy="777240"/>
           </a:xfrm>
           <a:prstGeom prst="roundRect">
             <a:avLst/>
@@ -5158,14 +5508,14 @@
       </p:sp>
       <p:sp>
         <p:nvSpPr>
-          <p:cNvPr id="47" name="Rectangle 46"/>
+          <p:cNvPr id="55" name="Rectangle 54"/>
           <p:cNvSpPr/>
           <p:nvPr/>
         </p:nvSpPr>
         <p:spPr>
           <a:xfrm>
-            <a:off x="3256635" y="5285232"/>
-            <a:ext cx="91440" cy="1280160"/>
+            <a:off x="3256635" y="5806440"/>
+            <a:ext cx="82296" cy="777240"/>
           </a:xfrm>
           <a:prstGeom prst="rect">
             <a:avLst/>
@@ -5202,14 +5552,14 @@
       </p:sp>
       <p:sp>
         <p:nvSpPr>
-          <p:cNvPr id="48" name="TextBox 47"/>
+          <p:cNvPr id="56" name="TextBox 55"/>
           <p:cNvSpPr txBox="1"/>
           <p:nvPr/>
         </p:nvSpPr>
         <p:spPr>
           <a:xfrm>
-            <a:off x="3530955" y="5431536"/>
-            <a:ext cx="2313432" cy="365760"/>
+            <a:off x="3494379" y="5897879"/>
+            <a:ext cx="2359152" cy="292608"/>
           </a:xfrm>
           <a:prstGeom prst="rect">
             <a:avLst/>
@@ -5224,31 +5574,31 @@
           <a:p>
             <a:pPr algn="l">
               <a:spcAft>
-                <a:spcPts val="200"/>
+                <a:spcPts val="100"/>
               </a:spcAft>
             </a:pPr>
             <a:r>
-              <a:rPr sz="1250" b="1">
+              <a:rPr sz="1100" b="1">
                 <a:solidFill>
                   <a:srgbClr val="5A97F5"/>
                 </a:solidFill>
                 <a:latin typeface="Calibri"/>
               </a:rPr>
-              <a:t>Standardization &amp; reuse</a:t>
-            </a:r>
-          </a:p>
-        </p:txBody>
-      </p:sp>
-      <p:sp>
-        <p:nvSpPr>
-          <p:cNvPr id="49" name="TextBox 48"/>
+              <a:t>Standardization</a:t>
+            </a:r>
+          </a:p>
+        </p:txBody>
+      </p:sp>
+      <p:sp>
+        <p:nvSpPr>
+          <p:cNvPr id="57" name="TextBox 56"/>
           <p:cNvSpPr txBox="1"/>
           <p:nvPr/>
         </p:nvSpPr>
         <p:spPr>
           <a:xfrm>
-            <a:off x="3530955" y="5815584"/>
-            <a:ext cx="2267712" cy="685800"/>
+            <a:off x="3494379" y="6190488"/>
+            <a:ext cx="2340864" cy="365760"/>
           </a:xfrm>
           <a:prstGeom prst="rect">
             <a:avLst/>
@@ -5263,32 +5613,31 @@
           <a:p>
             <a:pPr algn="l">
               <a:spcAft>
-                <a:spcPts val="200"/>
+                <a:spcPts val="100"/>
               </a:spcAft>
             </a:pPr>
             <a:r>
-              <a:rPr sz="950" b="0">
+              <a:rPr sz="900" b="0">
                 <a:solidFill>
                   <a:srgbClr val="9AAAC6"/>
                 </a:solidFill>
                 <a:latin typeface="Calibri"/>
               </a:rPr>
-              <a:t>One standard SSOT (20 sections) per IP
-— less quality variance, more reuse</a:t>
-            </a:r>
-          </a:p>
-        </p:txBody>
-      </p:sp>
-      <p:sp>
-        <p:nvSpPr>
-          <p:cNvPr id="50" name="Rounded Rectangle 49"/>
+              <a:t>one SSOT → consistent IP, reuse</a:t>
+            </a:r>
+          </a:p>
+        </p:txBody>
+      </p:sp>
+      <p:sp>
+        <p:nvSpPr>
+          <p:cNvPr id="58" name="Rounded Rectangle 57"/>
           <p:cNvSpPr/>
           <p:nvPr/>
         </p:nvSpPr>
         <p:spPr>
           <a:xfrm>
-            <a:off x="6210147" y="5285232"/>
-            <a:ext cx="2724912" cy="1280160"/>
+            <a:off x="6210147" y="5806440"/>
+            <a:ext cx="2724912" cy="777240"/>
           </a:xfrm>
           <a:prstGeom prst="roundRect">
             <a:avLst/>
@@ -5327,14 +5676,14 @@
       </p:sp>
       <p:sp>
         <p:nvSpPr>
-          <p:cNvPr id="51" name="Rectangle 50"/>
+          <p:cNvPr id="59" name="Rectangle 58"/>
           <p:cNvSpPr/>
           <p:nvPr/>
         </p:nvSpPr>
         <p:spPr>
           <a:xfrm>
-            <a:off x="6210147" y="5285232"/>
-            <a:ext cx="91440" cy="1280160"/>
+            <a:off x="6210147" y="5806440"/>
+            <a:ext cx="82296" cy="777240"/>
           </a:xfrm>
           <a:prstGeom prst="rect">
             <a:avLst/>
@@ -5371,14 +5720,14 @@
       </p:sp>
       <p:sp>
         <p:nvSpPr>
-          <p:cNvPr id="52" name="TextBox 51"/>
+          <p:cNvPr id="60" name="TextBox 59"/>
           <p:cNvSpPr txBox="1"/>
           <p:nvPr/>
         </p:nvSpPr>
         <p:spPr>
           <a:xfrm>
-            <a:off x="6484467" y="5431536"/>
-            <a:ext cx="2313432" cy="365760"/>
+            <a:off x="6447891" y="5897879"/>
+            <a:ext cx="2359152" cy="292608"/>
           </a:xfrm>
           <a:prstGeom prst="rect">
             <a:avLst/>
@@ -5393,31 +5742,31 @@
           <a:p>
             <a:pPr algn="l">
               <a:spcAft>
-                <a:spcPts val="200"/>
+                <a:spcPts val="100"/>
               </a:spcAft>
             </a:pPr>
             <a:r>
-              <a:rPr sz="1250" b="1">
+              <a:rPr sz="1100" b="1">
                 <a:solidFill>
                   <a:srgbClr val="4FC284"/>
                 </a:solidFill>
                 <a:latin typeface="Calibri"/>
               </a:rPr>
-              <a:t>Traceability &amp; auto-checks</a:t>
-            </a:r>
-          </a:p>
-        </p:txBody>
-      </p:sp>
-      <p:sp>
-        <p:nvSpPr>
-          <p:cNvPr id="53" name="TextBox 52"/>
+              <a:t>Traceability</a:t>
+            </a:r>
+          </a:p>
+        </p:txBody>
+      </p:sp>
+      <p:sp>
+        <p:nvSpPr>
+          <p:cNvPr id="61" name="TextBox 60"/>
           <p:cNvSpPr txBox="1"/>
           <p:nvPr/>
         </p:nvSpPr>
         <p:spPr>
           <a:xfrm>
-            <a:off x="6484467" y="5815584"/>
-            <a:ext cx="2267712" cy="685800"/>
+            <a:off x="6447891" y="6190488"/>
+            <a:ext cx="2340864" cy="365760"/>
           </a:xfrm>
           <a:prstGeom prst="rect">
             <a:avLst/>
@@ -5432,32 +5781,31 @@
           <a:p>
             <a:pPr algn="l">
               <a:spcAft>
-                <a:spcPts val="200"/>
+                <a:spcPts val="100"/>
               </a:spcAft>
             </a:pPr>
             <a:r>
-              <a:rPr sz="950" b="0">
+              <a:rPr sz="900" b="0">
                 <a:solidFill>
                   <a:srgbClr val="9AAAC6"/>
                 </a:solidFill>
                 <a:latin typeface="Calibri"/>
               </a:rPr>
-              <a:t>RTL derived from spec + stage gates
-catch defects early; fully auditable</a:t>
-            </a:r>
-          </a:p>
-        </p:txBody>
-      </p:sp>
-      <p:sp>
-        <p:nvSpPr>
-          <p:cNvPr id="54" name="Rounded Rectangle 53"/>
+              <a:t>spec→RTL + gates catch defects</a:t>
+            </a:r>
+          </a:p>
+        </p:txBody>
+      </p:sp>
+      <p:sp>
+        <p:nvSpPr>
+          <p:cNvPr id="62" name="Rounded Rectangle 61"/>
           <p:cNvSpPr/>
           <p:nvPr/>
         </p:nvSpPr>
         <p:spPr>
           <a:xfrm>
-            <a:off x="9163659" y="5285232"/>
-            <a:ext cx="2724912" cy="1280160"/>
+            <a:off x="9163659" y="5806440"/>
+            <a:ext cx="2724912" cy="777240"/>
           </a:xfrm>
           <a:prstGeom prst="roundRect">
             <a:avLst/>
@@ -5496,14 +5844,14 @@
       </p:sp>
       <p:sp>
         <p:nvSpPr>
-          <p:cNvPr id="55" name="Rectangle 54"/>
+          <p:cNvPr id="63" name="Rectangle 62"/>
           <p:cNvSpPr/>
           <p:nvPr/>
         </p:nvSpPr>
         <p:spPr>
           <a:xfrm>
-            <a:off x="9163659" y="5285232"/>
-            <a:ext cx="91440" cy="1280160"/>
+            <a:off x="9163659" y="5806440"/>
+            <a:ext cx="82296" cy="777240"/>
           </a:xfrm>
           <a:prstGeom prst="rect">
             <a:avLst/>
@@ -5540,14 +5888,14 @@
       </p:sp>
       <p:sp>
         <p:nvSpPr>
-          <p:cNvPr id="56" name="TextBox 55"/>
+          <p:cNvPr id="64" name="TextBox 63"/>
           <p:cNvSpPr txBox="1"/>
           <p:nvPr/>
         </p:nvSpPr>
         <p:spPr>
           <a:xfrm>
-            <a:off x="9437979" y="5431536"/>
-            <a:ext cx="2313432" cy="365760"/>
+            <a:off x="9401403" y="5897879"/>
+            <a:ext cx="2359152" cy="292608"/>
           </a:xfrm>
           <a:prstGeom prst="rect">
             <a:avLst/>
@@ -5562,31 +5910,31 @@
           <a:p>
             <a:pPr algn="l">
               <a:spcAft>
-                <a:spcPts val="200"/>
+                <a:spcPts val="100"/>
               </a:spcAft>
             </a:pPr>
             <a:r>
-              <a:rPr sz="1250" b="1">
+              <a:rPr sz="1100" b="1">
                 <a:solidFill>
                   <a:srgbClr val="EAA83A"/>
                 </a:solidFill>
                 <a:latin typeface="Calibri"/>
               </a:rPr>
-              <a:t>Knowledge as an asset</a:t>
-            </a:r>
-          </a:p>
-        </p:txBody>
-      </p:sp>
-      <p:sp>
-        <p:nvSpPr>
-          <p:cNvPr id="57" name="TextBox 56"/>
+              <a:t>Knowledge asset</a:t>
+            </a:r>
+          </a:p>
+        </p:txBody>
+      </p:sp>
+      <p:sp>
+        <p:nvSpPr>
+          <p:cNvPr id="65" name="TextBox 64"/>
           <p:cNvSpPr txBox="1"/>
           <p:nvPr/>
         </p:nvSpPr>
         <p:spPr>
           <a:xfrm>
-            <a:off x="9437979" y="5815584"/>
-            <a:ext cx="2267712" cy="685800"/>
+            <a:off x="9401403" y="6190488"/>
+            <a:ext cx="2340864" cy="365760"/>
           </a:xfrm>
           <a:prstGeom prst="rect">
             <a:avLst/>
@@ -5601,18 +5949,17 @@
           <a:p>
             <a:pPr algn="l">
               <a:spcAft>
-                <a:spcPts val="200"/>
+                <a:spcPts val="100"/>
               </a:spcAft>
             </a:pPr>
             <a:r>
-              <a:rPr sz="950" b="0">
+              <a:rPr sz="900" b="0">
                 <a:solidFill>
                   <a:srgbClr val="9AAAC6"/>
                 </a:solidFill>
                 <a:latin typeface="Calibri"/>
               </a:rPr>
-              <a:t>Captures DB &amp; Q&amp;A as a formal spec —
-design knowledge becomes reusable</a:t>
+              <a:t>DB &amp; Q&amp;A captured as formal spec</a:t>
             </a:r>
           </a:p>
         </p:txBody>

</xml_diff>